<commit_message>
feat(demo): secure TG bind-token, light MTS web for QR, pitch QR slide
Telegram activates only via one-time app key; light /app page for mobile jury instead of heavy Flet; cloudflared QR tooling.

Co-authored-by: Cursor <cursoragent@cursor.com>
</commit_message>
<xml_diff>
--- a/docs/presentation_track1.pptx
+++ b/docs/presentation_track1.pptx
@@ -17,6 +17,7 @@
     <p:sldId id="265" r:id="rId16"/>
     <p:sldId id="266" r:id="rId17"/>
     <p:sldId id="267" r:id="rId18"/>
+    <p:sldId id="268" r:id="rId19"/>
   </p:sldIdLst>
   <p:sldSz cx="12191695" cy="6858000" type="screen4x3"/>
   <p:notesSz cx="6858000" cy="9144000"/>
@@ -4221,7 +4222,7 @@
                 </a:solidFill>
                 <a:latin typeface="Arial"/>
               </a:rPr>
-              <a:t>10/12</a:t>
+              <a:t>10/13</a:t>
             </a:r>
           </a:p>
         </p:txBody>
@@ -5315,7 +5316,7 @@
                 </a:solidFill>
                 <a:latin typeface="Arial"/>
               </a:rPr>
-              <a:t>11/12</a:t>
+              <a:t>11/13</a:t>
             </a:r>
           </a:p>
         </p:txBody>
@@ -5329,6 +5330,606 @@
 </file>
 
 <file path=ppt/slides/slide12.xml><?xml version="1.0" encoding="utf-8"?>
+<p:sld xmlns:a="http://schemas.openxmlformats.org/drawingml/2006/main" xmlns:p="http://schemas.openxmlformats.org/presentationml/2006/main" xmlns:r="http://schemas.openxmlformats.org/officeDocument/2006/relationships">
+  <p:cSld>
+    <p:bg>
+      <p:bgPr>
+        <a:solidFill>
+          <a:srgbClr val="F2F2F4"/>
+        </a:solidFill>
+        <a:effectLst/>
+      </p:bgPr>
+    </p:bg>
+    <p:spTree>
+      <p:nvGrpSpPr>
+        <p:cNvPr id="1" name=""/>
+        <p:cNvGrpSpPr/>
+        <p:nvPr/>
+      </p:nvGrpSpPr>
+      <p:grpSpPr/>
+      <p:sp>
+        <p:nvSpPr>
+          <p:cNvPr id="2" name="Rectangle 1"/>
+          <p:cNvSpPr/>
+          <p:nvPr/>
+        </p:nvSpPr>
+        <p:spPr>
+          <a:xfrm>
+            <a:off x="0" y="0"/>
+            <a:ext cx="12191695" cy="384048"/>
+          </a:xfrm>
+          <a:prstGeom prst="rect">
+            <a:avLst/>
+          </a:prstGeom>
+          <a:solidFill>
+            <a:srgbClr val="E30611"/>
+          </a:solidFill>
+          <a:ln>
+            <a:noFill/>
+          </a:ln>
+        </p:spPr>
+        <p:style>
+          <a:lnRef idx="1">
+            <a:schemeClr val="accent1"/>
+          </a:lnRef>
+          <a:fillRef idx="3">
+            <a:schemeClr val="accent1"/>
+          </a:fillRef>
+          <a:effectRef idx="2">
+            <a:schemeClr val="accent1"/>
+          </a:effectRef>
+          <a:fontRef idx="minor">
+            <a:schemeClr val="lt1"/>
+          </a:fontRef>
+        </p:style>
+        <p:txBody>
+          <a:bodyPr rtlCol="0" anchor="ctr"/>
+          <a:lstStyle/>
+          <a:p>
+            <a:pPr algn="ctr"/>
+          </a:p>
+        </p:txBody>
+      </p:sp>
+      <p:sp>
+        <p:nvSpPr>
+          <p:cNvPr id="3" name="TextBox 2"/>
+          <p:cNvSpPr txBox="1"/>
+          <p:nvPr/>
+        </p:nvSpPr>
+        <p:spPr>
+          <a:xfrm>
+            <a:off x="502920" y="54864"/>
+            <a:ext cx="9144000" cy="292608"/>
+          </a:xfrm>
+          <a:prstGeom prst="rect">
+            <a:avLst/>
+          </a:prstGeom>
+          <a:noFill/>
+        </p:spPr>
+        <p:txBody>
+          <a:bodyPr wrap="none">
+            <a:spAutoFit/>
+          </a:bodyPr>
+          <a:lstStyle/>
+          <a:p>
+            <a:pPr algn="l">
+              <a:spcAft>
+                <a:spcPts val="0"/>
+              </a:spcAft>
+            </a:pPr>
+            <a:r>
+              <a:rPr sz="1100" b="1">
+                <a:solidFill>
+                  <a:srgbClr val="FFFFFF"/>
+                </a:solidFill>
+                <a:latin typeface="Arial"/>
+              </a:rPr>
+              <a:t>Попробуйте сами · приложение МТС</a:t>
+            </a:r>
+          </a:p>
+        </p:txBody>
+      </p:sp>
+      <p:sp>
+        <p:nvSpPr>
+          <p:cNvPr id="4" name="TextBox 3"/>
+          <p:cNvSpPr txBox="1"/>
+          <p:nvPr/>
+        </p:nvSpPr>
+        <p:spPr>
+          <a:xfrm>
+            <a:off x="502920" y="594360"/>
+            <a:ext cx="11155680" cy="640080"/>
+          </a:xfrm>
+          <a:prstGeom prst="rect">
+            <a:avLst/>
+          </a:prstGeom>
+          <a:noFill/>
+        </p:spPr>
+        <p:txBody>
+          <a:bodyPr wrap="square">
+            <a:spAutoFit/>
+          </a:bodyPr>
+          <a:lstStyle/>
+          <a:p>
+            <a:pPr algn="l">
+              <a:spcAft>
+                <a:spcPts val="400"/>
+              </a:spcAft>
+            </a:pPr>
+            <a:r>
+              <a:rPr sz="3000" b="1">
+                <a:solidFill>
+                  <a:srgbClr val="1A1A1A"/>
+                </a:solidFill>
+                <a:latin typeface="Arial"/>
+              </a:rPr>
+              <a:t>Откройте веб-приложение по QR</a:t>
+            </a:r>
+          </a:p>
+        </p:txBody>
+      </p:sp>
+      <p:sp>
+        <p:nvSpPr>
+          <p:cNvPr id="5" name="TextBox 4"/>
+          <p:cNvSpPr txBox="1"/>
+          <p:nvPr/>
+        </p:nvSpPr>
+        <p:spPr>
+          <a:xfrm>
+            <a:off x="502920" y="1097280"/>
+            <a:ext cx="11155680" cy="411480"/>
+          </a:xfrm>
+          <a:prstGeom prst="rect">
+            <a:avLst/>
+          </a:prstGeom>
+          <a:noFill/>
+        </p:spPr>
+        <p:txBody>
+          <a:bodyPr wrap="none">
+            <a:spAutoFit/>
+          </a:bodyPr>
+          <a:lstStyle/>
+          <a:p>
+            <a:pPr algn="l">
+              <a:spcAft>
+                <a:spcPts val="0"/>
+              </a:spcAft>
+            </a:pPr>
+            <a:r>
+              <a:rPr sz="1500" b="0">
+                <a:solidFill>
+                  <a:srgbClr val="5C5C62"/>
+                </a:solidFill>
+                <a:latin typeface="Arial"/>
+              </a:rPr>
+              <a:t>Лёгкая страница МТС на телефоне. Telegram — только кнопка с личным ключом.</a:t>
+            </a:r>
+          </a:p>
+        </p:txBody>
+      </p:sp>
+      <p:sp>
+        <p:nvSpPr>
+          <p:cNvPr id="6" name="Rounded Rectangle 5"/>
+          <p:cNvSpPr/>
+          <p:nvPr/>
+        </p:nvSpPr>
+        <p:spPr>
+          <a:xfrm>
+            <a:off x="502920" y="1691640"/>
+            <a:ext cx="5852160" cy="4206240"/>
+          </a:xfrm>
+          <a:prstGeom prst="roundRect">
+            <a:avLst>
+              <a:gd name="adj" fmla="val 8000"/>
+            </a:avLst>
+          </a:prstGeom>
+          <a:solidFill>
+            <a:srgbClr val="FFFFFF"/>
+          </a:solidFill>
+          <a:ln>
+            <a:noFill/>
+          </a:ln>
+        </p:spPr>
+        <p:style>
+          <a:lnRef idx="1">
+            <a:schemeClr val="accent1"/>
+          </a:lnRef>
+          <a:fillRef idx="3">
+            <a:schemeClr val="accent1"/>
+          </a:fillRef>
+          <a:effectRef idx="2">
+            <a:schemeClr val="accent1"/>
+          </a:effectRef>
+          <a:fontRef idx="minor">
+            <a:schemeClr val="lt1"/>
+          </a:fontRef>
+        </p:style>
+        <p:txBody>
+          <a:bodyPr rtlCol="0" anchor="ctr"/>
+          <a:lstStyle/>
+          <a:p>
+            <a:pPr algn="ctr"/>
+          </a:p>
+        </p:txBody>
+      </p:sp>
+      <p:sp>
+        <p:nvSpPr>
+          <p:cNvPr id="7" name="TextBox 6"/>
+          <p:cNvSpPr txBox="1"/>
+          <p:nvPr/>
+        </p:nvSpPr>
+        <p:spPr>
+          <a:xfrm>
+            <a:off x="777240" y="1965960"/>
+            <a:ext cx="5303520" cy="3657600"/>
+          </a:xfrm>
+          <a:prstGeom prst="rect">
+            <a:avLst/>
+          </a:prstGeom>
+          <a:noFill/>
+        </p:spPr>
+        <p:txBody>
+          <a:bodyPr wrap="square">
+            <a:spAutoFit/>
+          </a:bodyPr>
+          <a:lstStyle/>
+          <a:p>
+            <a:pPr algn="l">
+              <a:spcAft>
+                <a:spcPts val="1000"/>
+              </a:spcAft>
+            </a:pPr>
+            <a:r>
+              <a:rPr sz="1800" b="1">
+                <a:solidFill>
+                  <a:srgbClr val="1A1A1A"/>
+                </a:solidFill>
+                <a:latin typeface="Arial"/>
+              </a:rPr>
+              <a:t>Как зайти</a:t>
+            </a:r>
+          </a:p>
+          <a:p>
+            <a:pPr algn="l">
+              <a:spcAft>
+                <a:spcPts val="600"/>
+              </a:spcAft>
+            </a:pPr>
+            <a:r>
+              <a:rPr sz="1400" b="0">
+                <a:solidFill>
+                  <a:srgbClr val="1A1A1A"/>
+                </a:solidFill>
+                <a:latin typeface="Arial"/>
+              </a:rPr>
+              <a:t>1. Сканируйте QR → сайт МТС (Flet)</a:t>
+            </a:r>
+          </a:p>
+          <a:p>
+            <a:pPr algn="l">
+              <a:spcAft>
+                <a:spcPts val="600"/>
+              </a:spcAft>
+            </a:pPr>
+            <a:r>
+              <a:rPr sz="1400" b="0">
+                <a:solidFill>
+                  <a:srgbClr val="1A1A1A"/>
+                </a:solidFill>
+                <a:latin typeface="Arial"/>
+              </a:rPr>
+              <a:t>2. Номер → согласие → Подключить</a:t>
+            </a:r>
+          </a:p>
+          <a:p>
+            <a:pPr algn="l">
+              <a:spcAft>
+                <a:spcPts val="600"/>
+              </a:spcAft>
+            </a:pPr>
+            <a:r>
+              <a:rPr sz="1400" b="0">
+                <a:solidFill>
+                  <a:srgbClr val="1A1A1A"/>
+                </a:solidFill>
+                <a:latin typeface="Arial"/>
+              </a:rPr>
+              <a:t>3. «Перейти в Telegram» — личный ключ</a:t>
+            </a:r>
+          </a:p>
+          <a:p>
+            <a:pPr algn="l">
+              <a:spcAft>
+                <a:spcPts val="600"/>
+              </a:spcAft>
+            </a:pPr>
+            <a:r>
+              <a:rPr sz="1400" b="0">
+                <a:solidFill>
+                  <a:srgbClr val="1A1A1A"/>
+                </a:solidFill>
+                <a:latin typeface="Arial"/>
+              </a:rPr>
+              <a:t>4. Подтвердить → демо-звонок в боте</a:t>
+            </a:r>
+          </a:p>
+          <a:p>
+            <a:pPr algn="l">
+              <a:spcAft>
+                <a:spcPts val="600"/>
+              </a:spcAft>
+            </a:pPr>
+            <a:r>
+              <a:rPr sz="1400" b="0">
+                <a:solidFill>
+                  <a:srgbClr val="1A1A1A"/>
+                </a:solidFill>
+                <a:latin typeface="Arial"/>
+              </a:rPr>
+              <a:t/>
+            </a:r>
+          </a:p>
+          <a:p>
+            <a:pPr algn="l">
+              <a:spcAft>
+                <a:spcPts val="600"/>
+              </a:spcAft>
+            </a:pPr>
+            <a:r>
+              <a:rPr sz="1400" b="0">
+                <a:solidFill>
+                  <a:srgbClr val="1A1A1A"/>
+                </a:solidFill>
+                <a:latin typeface="Arial"/>
+              </a:rPr>
+              <a:t>Ссылка: https://lay-mind-excluded-insurance.trycloudflare.com</a:t>
+            </a:r>
+          </a:p>
+          <a:p>
+            <a:pPr algn="l">
+              <a:spcAft>
+                <a:spcPts val="600"/>
+              </a:spcAft>
+            </a:pPr>
+            <a:r>
+              <a:rPr sz="1400" b="0">
+                <a:solidFill>
+                  <a:srgbClr val="1A1A1A"/>
+                </a:solidFill>
+                <a:latin typeface="Arial"/>
+              </a:rPr>
+              <a:t/>
+            </a:r>
+          </a:p>
+          <a:p>
+            <a:pPr algn="l">
+              <a:spcAft>
+                <a:spcPts val="600"/>
+              </a:spcAft>
+            </a:pPr>
+            <a:r>
+              <a:rPr sz="1400" b="0">
+                <a:solidFill>
+                  <a:srgbClr val="5C5C62"/>
+                </a:solidFill>
+                <a:latin typeface="Arial"/>
+              </a:rPr>
+              <a:t>QR всегда на веб, не на t.me.</a:t>
+            </a:r>
+          </a:p>
+          <a:p>
+            <a:pPr algn="l">
+              <a:spcAft>
+                <a:spcPts val="600"/>
+              </a:spcAft>
+            </a:pPr>
+            <a:r>
+              <a:rPr sz="1400" b="0">
+                <a:solidFill>
+                  <a:srgbClr val="5C5C62"/>
+                </a:solidFill>
+                <a:latin typeface="Arial"/>
+              </a:rPr>
+              <a:t>Жюри без Wi‑Fi: DEMO_WEB_URL (cloudflared).</a:t>
+            </a:r>
+          </a:p>
+        </p:txBody>
+      </p:sp>
+      <p:sp>
+        <p:nvSpPr>
+          <p:cNvPr id="8" name="Rounded Rectangle 7"/>
+          <p:cNvSpPr/>
+          <p:nvPr/>
+        </p:nvSpPr>
+        <p:spPr>
+          <a:xfrm>
+            <a:off x="6675120" y="1691640"/>
+            <a:ext cx="4846320" cy="4206240"/>
+          </a:xfrm>
+          <a:prstGeom prst="roundRect">
+            <a:avLst>
+              <a:gd name="adj" fmla="val 8000"/>
+            </a:avLst>
+          </a:prstGeom>
+          <a:solidFill>
+            <a:srgbClr val="FFFFFF"/>
+          </a:solidFill>
+          <a:ln>
+            <a:noFill/>
+          </a:ln>
+        </p:spPr>
+        <p:style>
+          <a:lnRef idx="1">
+            <a:schemeClr val="accent1"/>
+          </a:lnRef>
+          <a:fillRef idx="3">
+            <a:schemeClr val="accent1"/>
+          </a:fillRef>
+          <a:effectRef idx="2">
+            <a:schemeClr val="accent1"/>
+          </a:effectRef>
+          <a:fontRef idx="minor">
+            <a:schemeClr val="lt1"/>
+          </a:fontRef>
+        </p:style>
+        <p:txBody>
+          <a:bodyPr rtlCol="0" anchor="ctr"/>
+          <a:lstStyle/>
+          <a:p>
+            <a:pPr algn="ctr"/>
+          </a:p>
+        </p:txBody>
+      </p:sp>
+      <p:pic>
+        <p:nvPicPr>
+          <p:cNvPr id="9" name="Picture 8" descr="demo_qr.png"/>
+          <p:cNvPicPr>
+            <a:picLocks noChangeAspect="1"/>
+          </p:cNvPicPr>
+          <p:nvPr/>
+        </p:nvPicPr>
+        <p:blipFill>
+          <a:blip r:embed="rId2"/>
+          <a:stretch>
+            <a:fillRect/>
+          </a:stretch>
+        </p:blipFill>
+        <p:spPr>
+          <a:xfrm>
+            <a:off x="7452360" y="2057400"/>
+            <a:ext cx="3291840" cy="3291840"/>
+          </a:xfrm>
+          <a:prstGeom prst="rect">
+            <a:avLst/>
+          </a:prstGeom>
+        </p:spPr>
+      </p:pic>
+      <p:sp>
+        <p:nvSpPr>
+          <p:cNvPr id="10" name="TextBox 9"/>
+          <p:cNvSpPr txBox="1"/>
+          <p:nvPr/>
+        </p:nvSpPr>
+        <p:spPr>
+          <a:xfrm>
+            <a:off x="6858000" y="5440680"/>
+            <a:ext cx="4480560" cy="320040"/>
+          </a:xfrm>
+          <a:prstGeom prst="rect">
+            <a:avLst/>
+          </a:prstGeom>
+          <a:noFill/>
+        </p:spPr>
+        <p:txBody>
+          <a:bodyPr wrap="none">
+            <a:spAutoFit/>
+          </a:bodyPr>
+          <a:lstStyle/>
+          <a:p>
+            <a:pPr algn="ctr">
+              <a:spcAft>
+                <a:spcPts val="0"/>
+              </a:spcAft>
+            </a:pPr>
+            <a:r>
+              <a:rPr sz="1100" b="0">
+                <a:solidFill>
+                  <a:srgbClr val="8A8A90"/>
+                </a:solidFill>
+                <a:latin typeface="Arial"/>
+              </a:rPr>
+              <a:t>https://lay-mind-excluded-insurance.trycloudflare.com</a:t>
+            </a:r>
+          </a:p>
+        </p:txBody>
+      </p:sp>
+      <p:sp>
+        <p:nvSpPr>
+          <p:cNvPr id="11" name="TextBox 10"/>
+          <p:cNvSpPr txBox="1"/>
+          <p:nvPr/>
+        </p:nvSpPr>
+        <p:spPr>
+          <a:xfrm>
+            <a:off x="502920" y="6492240"/>
+            <a:ext cx="9144000" cy="256032"/>
+          </a:xfrm>
+          <a:prstGeom prst="rect">
+            <a:avLst/>
+          </a:prstGeom>
+          <a:noFill/>
+        </p:spPr>
+        <p:txBody>
+          <a:bodyPr wrap="none">
+            <a:spAutoFit/>
+          </a:bodyPr>
+          <a:lstStyle/>
+          <a:p>
+            <a:pPr algn="l">
+              <a:spcAft>
+                <a:spcPts val="0"/>
+              </a:spcAft>
+            </a:pPr>
+            <a:r>
+              <a:rPr sz="1000" b="0">
+                <a:solidFill>
+                  <a:srgbClr val="8A8A90"/>
+                </a:solidFill>
+                <a:latin typeface="Arial"/>
+              </a:rPr>
+              <a:t>ИИ-секретарь входящих · прототип для МТС</a:t>
+            </a:r>
+          </a:p>
+        </p:txBody>
+      </p:sp>
+      <p:sp>
+        <p:nvSpPr>
+          <p:cNvPr id="12" name="TextBox 11"/>
+          <p:cNvSpPr txBox="1"/>
+          <p:nvPr/>
+        </p:nvSpPr>
+        <p:spPr>
+          <a:xfrm>
+            <a:off x="11155680" y="6492240"/>
+            <a:ext cx="731520" cy="256032"/>
+          </a:xfrm>
+          <a:prstGeom prst="rect">
+            <a:avLst/>
+          </a:prstGeom>
+          <a:noFill/>
+        </p:spPr>
+        <p:txBody>
+          <a:bodyPr wrap="none">
+            <a:spAutoFit/>
+          </a:bodyPr>
+          <a:lstStyle/>
+          <a:p>
+            <a:pPr algn="r">
+              <a:spcAft>
+                <a:spcPts val="0"/>
+              </a:spcAft>
+            </a:pPr>
+            <a:r>
+              <a:rPr sz="1000" b="0">
+                <a:solidFill>
+                  <a:srgbClr val="8A8A90"/>
+                </a:solidFill>
+                <a:latin typeface="Arial"/>
+              </a:rPr>
+              <a:t>12/13</a:t>
+            </a:r>
+          </a:p>
+        </p:txBody>
+      </p:sp>
+    </p:spTree>
+  </p:cSld>
+  <p:clrMapOvr>
+    <a:masterClrMapping/>
+  </p:clrMapOvr>
+</p:sld>
+</file>
+
+<file path=ppt/slides/slide13.xml><?xml version="1.0" encoding="utf-8"?>
 <p:sld xmlns:a="http://schemas.openxmlformats.org/drawingml/2006/main" xmlns:p="http://schemas.openxmlformats.org/presentationml/2006/main" xmlns:r="http://schemas.openxmlformats.org/officeDocument/2006/relationships">
   <p:cSld>
     <p:bg>
@@ -5471,7 +6072,7 @@
                 </a:solidFill>
                 <a:latin typeface="Arial"/>
               </a:rPr>
-              <a:t>Дальше — живое демо. Вопросы после.</a:t>
+              <a:t>Дальше — живое демо и QR. Вопросы после.</a:t>
             </a:r>
           </a:p>
         </p:txBody>
@@ -6411,7 +7012,7 @@
                 </a:solidFill>
                 <a:latin typeface="Arial"/>
               </a:rPr>
-              <a:t>2/12</a:t>
+              <a:t>2/13</a:t>
             </a:r>
           </a:p>
         </p:txBody>
@@ -7339,7 +7940,7 @@
                 </a:solidFill>
                 <a:latin typeface="Arial"/>
               </a:rPr>
-              <a:t>3/12</a:t>
+              <a:t>3/13</a:t>
             </a:r>
           </a:p>
         </p:txBody>
@@ -8063,7 +8664,7 @@
                 </a:solidFill>
                 <a:latin typeface="Arial"/>
               </a:rPr>
-              <a:t>4/12</a:t>
+              <a:t>4/13</a:t>
             </a:r>
           </a:p>
         </p:txBody>
@@ -8748,7 +9349,7 @@
                 </a:solidFill>
                 <a:latin typeface="Arial"/>
               </a:rPr>
-              <a:t>5/12</a:t>
+              <a:t>5/13</a:t>
             </a:r>
           </a:p>
         </p:txBody>
@@ -9627,7 +10228,7 @@
                 </a:solidFill>
                 <a:latin typeface="Arial"/>
               </a:rPr>
-              <a:t>6/12</a:t>
+              <a:t>6/13</a:t>
             </a:r>
           </a:p>
         </p:txBody>
@@ -10721,7 +11322,7 @@
                 </a:solidFill>
                 <a:latin typeface="Arial"/>
               </a:rPr>
-              <a:t>7/12</a:t>
+              <a:t>7/13</a:t>
             </a:r>
           </a:p>
         </p:txBody>
@@ -11834,7 +12435,7 @@
                 </a:solidFill>
                 <a:latin typeface="Arial"/>
               </a:rPr>
-              <a:t>8/12</a:t>
+              <a:t>8/13</a:t>
             </a:r>
           </a:p>
         </p:txBody>
@@ -12596,7 +13197,7 @@
                 </a:solidFill>
                 <a:latin typeface="Arial"/>
               </a:rPr>
-              <a:t>9/12</a:t>
+              <a:t>9/13</a:t>
             </a:r>
           </a:p>
         </p:txBody>

</xml_diff>

<commit_message>
docs(pitch): rewrite slide 7 with test coverage numbers and field QA
Replace Ivan-facing analytics copy with concrete suite metrics (14 modules, 60+ routing cases, 100+ checks) and noisy-room / multi-voice field runs in the main deck.
</commit_message>
<xml_diff>
--- a/docs/presentation_track1.pptx
+++ b/docs/presentation_track1.pptx
@@ -11,6 +11,7 @@
     <p:sldId id="259" r:id="rId5"/>
     <p:sldId id="261" r:id="rId6"/>
     <p:sldId id="265" r:id="rId7"/>
+    <p:sldId id="268" r:id="rId14"/>
     <p:sldId id="267" r:id="rId8"/>
     <p:sldId id="266" r:id="rId9"/>
   </p:sldIdLst>
@@ -4562,22 +4563,13 @@
               </a:spcAft>
             </a:pPr>
             <a:r>
-              <a:rPr sz="1000" b="0" dirty="0">
+              <a:rPr sz="1000">
                 <a:solidFill>
                   <a:srgbClr val="8A8A90"/>
                 </a:solidFill>
                 <a:latin typeface="Arial"/>
               </a:rPr>
-              <a:t>2/</a:t>
-            </a:r>
-            <a:r>
-              <a:rPr lang="ru-RU" sz="1000" b="0" dirty="0">
-                <a:solidFill>
-                  <a:srgbClr val="8A8A90"/>
-                </a:solidFill>
-                <a:latin typeface="Arial"/>
-              </a:rPr>
-              <a:t>8</a:t>
+              <a:t>2/9</a:t>
             </a:r>
             <a:endParaRPr sz="1000" b="0" dirty="0">
               <a:solidFill>
@@ -5530,22 +5522,13 @@
               </a:spcAft>
             </a:pPr>
             <a:r>
-              <a:rPr sz="1000" b="0" dirty="0">
+              <a:rPr sz="1000">
                 <a:solidFill>
                   <a:srgbClr val="8A8A90"/>
                 </a:solidFill>
                 <a:latin typeface="Arial"/>
               </a:rPr>
-              <a:t>3/</a:t>
-            </a:r>
-            <a:r>
-              <a:rPr lang="ru-RU" sz="1000" b="0" dirty="0">
-                <a:solidFill>
-                  <a:srgbClr val="8A8A90"/>
-                </a:solidFill>
-                <a:latin typeface="Arial"/>
-              </a:rPr>
-              <a:t>8</a:t>
+              <a:t>3/9</a:t>
             </a:r>
             <a:endParaRPr sz="1000" b="0" dirty="0">
               <a:solidFill>
@@ -6986,22 +6969,13 @@
               </a:spcAft>
             </a:pPr>
             <a:r>
-              <a:rPr sz="1000" b="0" dirty="0">
+              <a:rPr sz="1000">
                 <a:solidFill>
                   <a:srgbClr val="8A8A90"/>
                 </a:solidFill>
                 <a:latin typeface="Arial"/>
               </a:rPr>
-              <a:t>4/</a:t>
-            </a:r>
-            <a:r>
-              <a:rPr lang="ru-RU" sz="1000" b="0" dirty="0">
-                <a:solidFill>
-                  <a:srgbClr val="8A8A90"/>
-                </a:solidFill>
-                <a:latin typeface="Arial"/>
-              </a:rPr>
-              <a:t>8</a:t>
+              <a:t>4/9</a:t>
             </a:r>
             <a:endParaRPr sz="1000" b="0" dirty="0">
               <a:solidFill>
@@ -7962,31 +7936,13 @@
               </a:spcAft>
             </a:pPr>
             <a:r>
-              <a:rPr lang="ru-RU" sz="1000" b="0" dirty="0">
+              <a:rPr sz="1000">
                 <a:solidFill>
                   <a:srgbClr val="8A8A90"/>
                 </a:solidFill>
                 <a:latin typeface="Arial"/>
               </a:rPr>
-              <a:t>5</a:t>
-            </a:r>
-            <a:r>
-              <a:rPr lang="en-US" sz="1000" b="0" dirty="0">
-                <a:solidFill>
-                  <a:srgbClr val="8A8A90"/>
-                </a:solidFill>
-                <a:latin typeface="Arial"/>
-              </a:rPr>
-              <a:t>/</a:t>
-            </a:r>
-            <a:r>
-              <a:rPr lang="ru-RU" sz="1000" dirty="0">
-                <a:solidFill>
-                  <a:srgbClr val="8A8A90"/>
-                </a:solidFill>
-                <a:latin typeface="Arial"/>
-              </a:rPr>
-              <a:t>8</a:t>
+              <a:t>5/9</a:t>
             </a:r>
           </a:p>
         </p:txBody>
@@ -8909,31 +8865,13 @@
               </a:spcAft>
             </a:pPr>
             <a:r>
-              <a:rPr lang="en-US" sz="1000" dirty="0">
+              <a:rPr sz="1000">
                 <a:solidFill>
                   <a:srgbClr val="8A8A90"/>
                 </a:solidFill>
                 <a:latin typeface="Arial"/>
               </a:rPr>
-              <a:t>6</a:t>
-            </a:r>
-            <a:r>
-              <a:rPr sz="1000" b="0" dirty="0">
-                <a:solidFill>
-                  <a:srgbClr val="8A8A90"/>
-                </a:solidFill>
-                <a:latin typeface="Arial"/>
-              </a:rPr>
-              <a:t>/</a:t>
-            </a:r>
-            <a:r>
-              <a:rPr lang="en-US" sz="1000" b="0" dirty="0">
-                <a:solidFill>
-                  <a:srgbClr val="8A8A90"/>
-                </a:solidFill>
-                <a:latin typeface="Arial"/>
-              </a:rPr>
-              <a:t>8</a:t>
+              <a:t>6/9</a:t>
             </a:r>
             <a:endParaRPr sz="1000" b="0" dirty="0">
               <a:solidFill>
@@ -8953,7 +8891,7 @@
 </file>
 
 <file path=ppt/slides/slide7.xml><?xml version="1.0" encoding="utf-8"?>
-<p:sld xmlns:a="http://schemas.openxmlformats.org/drawingml/2006/main" xmlns:r="http://schemas.openxmlformats.org/officeDocument/2006/relationships" xmlns:p="http://schemas.openxmlformats.org/presentationml/2006/main">
+<p:sld xmlns:a="http://schemas.openxmlformats.org/drawingml/2006/main" xmlns:p="http://schemas.openxmlformats.org/presentationml/2006/main" xmlns:r="http://schemas.openxmlformats.org/officeDocument/2006/relationships">
   <p:cSld>
     <p:bg>
       <p:bgPr>
@@ -8969,14 +8907,7 @@
         <p:cNvGrpSpPr/>
         <p:nvPr/>
       </p:nvGrpSpPr>
-      <p:grpSpPr>
-        <a:xfrm>
-          <a:off x="0" y="0"/>
-          <a:ext cx="0" cy="0"/>
-          <a:chOff x="0" y="0"/>
-          <a:chExt cx="0" cy="0"/>
-        </a:xfrm>
-      </p:grpSpPr>
+      <p:grpSpPr/>
       <p:sp>
         <p:nvSpPr>
           <p:cNvPr id="2" name="Rectangle 1"/>
@@ -9017,7 +8948,6 @@
           <a:lstStyle/>
           <a:p>
             <a:pPr algn="ctr"/>
-            <a:endParaRPr/>
           </a:p>
         </p:txBody>
       </p:sp>
@@ -9030,7 +8960,7 @@
         <p:spPr>
           <a:xfrm>
             <a:off x="502920" y="54864"/>
-            <a:ext cx="1566454" cy="261610"/>
+            <a:ext cx="9144000" cy="292608"/>
           </a:xfrm>
           <a:prstGeom prst="rect">
             <a:avLst/>
@@ -9049,22 +8979,13 @@
               </a:spcAft>
             </a:pPr>
             <a:r>
-              <a:rPr lang="en-US" sz="1100" b="1" dirty="0" err="1">
+              <a:rPr sz="1100" b="1">
                 <a:solidFill>
                   <a:srgbClr val="FFFFFF"/>
                 </a:solidFill>
                 <a:latin typeface="Arial"/>
               </a:rPr>
-              <a:t>StartUp</a:t>
-            </a:r>
-            <a:r>
-              <a:rPr lang="en-US" sz="1100" b="1" dirty="0">
-                <a:solidFill>
-                  <a:srgbClr val="FFFFFF"/>
-                </a:solidFill>
-                <a:latin typeface="Arial"/>
-              </a:rPr>
-              <a:t> Space VSTU</a:t>
+              <a:t>StartUp Space VSTU</a:t>
             </a:r>
           </a:p>
         </p:txBody>
@@ -9078,7 +8999,7 @@
         <p:spPr>
           <a:xfrm>
             <a:off x="502920" y="594360"/>
-            <a:ext cx="11155680" cy="553998"/>
+            <a:ext cx="11155680" cy="640080"/>
           </a:xfrm>
           <a:prstGeom prst="rect">
             <a:avLst/>
@@ -9097,20 +9018,14 @@
               </a:spcAft>
             </a:pPr>
             <a:r>
-              <a:rPr lang="ru-RU" sz="3000" b="1" dirty="0">
+              <a:rPr sz="3000" b="1">
                 <a:solidFill>
                   <a:srgbClr val="1A1A1A"/>
                 </a:solidFill>
                 <a:latin typeface="Arial"/>
               </a:rPr>
-              <a:t>Кто мы?</a:t>
-            </a:r>
-            <a:endParaRPr sz="3000" b="1" dirty="0">
-              <a:solidFill>
-                <a:srgbClr val="1A1A1A"/>
-              </a:solidFill>
-              <a:latin typeface="Arial"/>
-            </a:endParaRPr>
+              <a:t>Тесты и аналитика</a:t>
+            </a:r>
           </a:p>
         </p:txBody>
       </p:sp>
@@ -9123,7 +9038,7 @@
         <p:spPr>
           <a:xfrm>
             <a:off x="502920" y="1097280"/>
-            <a:ext cx="3349122" cy="323165"/>
+            <a:ext cx="11155680" cy="411480"/>
           </a:xfrm>
           <a:prstGeom prst="rect">
             <a:avLst/>
@@ -9142,20 +9057,14 @@
               </a:spcAft>
             </a:pPr>
             <a:r>
-              <a:rPr lang="ru-RU" sz="1500" b="0" dirty="0">
-                <a:solidFill>
-                  <a:srgbClr val="5C5C62"/>
-                </a:solidFill>
-                <a:latin typeface="Arial"/>
-              </a:rPr>
-              <a:t>Великолепная команда – Два нуля!</a:t>
-            </a:r>
-            <a:endParaRPr sz="1500" b="0" dirty="0">
-              <a:solidFill>
-                <a:srgbClr val="5C5C62"/>
-              </a:solidFill>
-              <a:latin typeface="Arial"/>
-            </a:endParaRPr>
+              <a:rPr sz="1500" b="0">
+                <a:solidFill>
+                  <a:srgbClr val="5C5C62"/>
+                </a:solidFill>
+                <a:latin typeface="Arial"/>
+              </a:rPr>
+              <a:t>Покрыли автотестами почти весь продукт и прогнали голосом в реальных условиях.</a:t>
+            </a:r>
           </a:p>
         </p:txBody>
       </p:sp>
@@ -9167,8 +9076,8 @@
         </p:nvSpPr>
         <p:spPr>
           <a:xfrm>
-            <a:off x="1847609" y="1645920"/>
-            <a:ext cx="3657600" cy="4114800"/>
+            <a:off x="502920" y="1554480"/>
+            <a:ext cx="3566160" cy="1143000"/>
           </a:xfrm>
           <a:prstGeom prst="roundRect">
             <a:avLst>
@@ -9201,7 +9110,6 @@
           <a:lstStyle/>
           <a:p>
             <a:pPr algn="ctr"/>
-            <a:endParaRPr/>
           </a:p>
         </p:txBody>
       </p:sp>
@@ -9213,8 +9121,8 @@
         </p:nvSpPr>
         <p:spPr>
           <a:xfrm>
-            <a:off x="1797317" y="1651278"/>
-            <a:ext cx="73152" cy="4114800"/>
+            <a:off x="502920" y="1554480"/>
+            <a:ext cx="73152" cy="1143000"/>
           </a:xfrm>
           <a:prstGeom prst="rect">
             <a:avLst/>
@@ -9245,7 +9153,6 @@
           <a:lstStyle/>
           <a:p>
             <a:pPr algn="ctr"/>
-            <a:endParaRPr/>
           </a:p>
         </p:txBody>
       </p:sp>
@@ -9257,8 +9164,8 @@
         </p:nvSpPr>
         <p:spPr>
           <a:xfrm>
-            <a:off x="1901992" y="3874429"/>
-            <a:ext cx="675185" cy="323165"/>
+            <a:off x="685800" y="1719072"/>
+            <a:ext cx="3246120" cy="502920"/>
           </a:xfrm>
           <a:prstGeom prst="rect">
             <a:avLst/>
@@ -9277,20 +9184,14 @@
               </a:spcAft>
             </a:pPr>
             <a:r>
-              <a:rPr lang="ru-RU" sz="1500" b="1" dirty="0">
-                <a:solidFill>
-                  <a:srgbClr val="1A1A1A"/>
-                </a:solidFill>
-                <a:latin typeface="Arial"/>
-              </a:rPr>
-              <a:t>Влад</a:t>
-            </a:r>
-            <a:endParaRPr sz="1500" b="1" dirty="0">
-              <a:solidFill>
-                <a:srgbClr val="1A1A1A"/>
-              </a:solidFill>
-              <a:latin typeface="Arial"/>
-            </a:endParaRPr>
+              <a:rPr sz="2800" b="1">
+                <a:solidFill>
+                  <a:srgbClr val="E30611"/>
+                </a:solidFill>
+                <a:latin typeface="Arial"/>
+              </a:rPr>
+              <a:t>14</a:t>
+            </a:r>
           </a:p>
         </p:txBody>
       </p:sp>
@@ -9302,8 +9203,8 @@
         </p:nvSpPr>
         <p:spPr>
           <a:xfrm>
-            <a:off x="1932485" y="4236216"/>
-            <a:ext cx="3246120" cy="1544012"/>
+            <a:off x="685800" y="2212848"/>
+            <a:ext cx="3246120" cy="411480"/>
           </a:xfrm>
           <a:prstGeom prst="rect">
             <a:avLst/>
@@ -9311,159 +9212,25 @@
           <a:noFill/>
         </p:spPr>
         <p:txBody>
-          <a:bodyPr wrap="square">
+          <a:bodyPr wrap="none">
             <a:spAutoFit/>
           </a:bodyPr>
           <a:lstStyle/>
           <a:p>
             <a:pPr algn="l">
               <a:spcAft>
-                <a:spcPts val="400"/>
-              </a:spcAft>
-            </a:pPr>
-            <a:r>
-              <a:rPr lang="en-US" sz="1300" dirty="0">
-                <a:solidFill>
-                  <a:srgbClr val="5C5C62"/>
-                </a:solidFill>
-                <a:latin typeface="Arial"/>
-              </a:rPr>
-              <a:t>Backend QA Engineer</a:t>
-            </a:r>
-            <a:br>
-              <a:rPr lang="ru-RU" sz="1300" dirty="0">
-                <a:solidFill>
-                  <a:srgbClr val="5C5C62"/>
-                </a:solidFill>
-                <a:latin typeface="Arial"/>
-              </a:rPr>
-            </a:br>
-            <a:br>
-              <a:rPr lang="ru-RU" sz="1300" dirty="0">
-                <a:solidFill>
-                  <a:srgbClr val="5C5C62"/>
-                </a:solidFill>
-                <a:latin typeface="Arial"/>
-              </a:rPr>
-            </a:br>
-            <a:r>
-              <a:rPr lang="ru-RU" sz="1300" dirty="0">
-                <a:solidFill>
-                  <a:srgbClr val="5C5C62"/>
-                </a:solidFill>
-                <a:latin typeface="Arial"/>
-              </a:rPr>
-              <a:t>- Вид приложения</a:t>
-            </a:r>
-            <a:br>
-              <a:rPr lang="ru-RU" sz="1300" dirty="0">
-                <a:solidFill>
-                  <a:srgbClr val="5C5C62"/>
-                </a:solidFill>
-                <a:latin typeface="Arial"/>
-              </a:rPr>
-            </a:br>
-            <a:r>
-              <a:rPr lang="ru-RU" sz="1300" dirty="0">
-                <a:solidFill>
-                  <a:srgbClr val="5C5C62"/>
-                </a:solidFill>
-                <a:latin typeface="Arial"/>
-              </a:rPr>
-              <a:t>- </a:t>
-            </a:r>
-            <a:r>
-              <a:rPr lang="en-US" sz="1300" dirty="0" err="1">
-                <a:solidFill>
-                  <a:srgbClr val="5C5C62"/>
-                </a:solidFill>
-                <a:latin typeface="Arial"/>
-              </a:rPr>
-              <a:t>Tg</a:t>
-            </a:r>
-            <a:r>
-              <a:rPr lang="en-US" sz="1300" dirty="0">
-                <a:solidFill>
-                  <a:srgbClr val="5C5C62"/>
-                </a:solidFill>
-                <a:latin typeface="Arial"/>
-              </a:rPr>
-              <a:t>-</a:t>
-            </a:r>
-            <a:r>
-              <a:rPr lang="ru-RU" sz="1300" dirty="0">
-                <a:solidFill>
-                  <a:srgbClr val="5C5C62"/>
-                </a:solidFill>
-                <a:latin typeface="Arial"/>
-              </a:rPr>
-              <a:t>бот</a:t>
-            </a:r>
-          </a:p>
-          <a:p>
-            <a:pPr algn="l">
-              <a:spcAft>
-                <a:spcPts val="400"/>
-              </a:spcAft>
-            </a:pPr>
-            <a:r>
-              <a:rPr lang="ru-RU" sz="1300" b="0" dirty="0">
-                <a:solidFill>
-                  <a:srgbClr val="5C5C62"/>
-                </a:solidFill>
-                <a:latin typeface="Arial"/>
-              </a:rPr>
-              <a:t>- Безопасность</a:t>
-            </a:r>
-            <a:br>
-              <a:rPr lang="ru-RU" sz="1300" b="0" dirty="0">
-                <a:solidFill>
-                  <a:srgbClr val="5C5C62"/>
-                </a:solidFill>
-                <a:latin typeface="Arial"/>
-              </a:rPr>
-            </a:br>
-            <a:r>
-              <a:rPr lang="ru-RU" sz="1300" b="0" dirty="0">
-                <a:solidFill>
-                  <a:srgbClr val="5C5C62"/>
-                </a:solidFill>
-                <a:latin typeface="Arial"/>
-              </a:rPr>
-              <a:t> </a:t>
-            </a:r>
-            <a:br>
-              <a:rPr lang="ru-RU" sz="1300" dirty="0">
-                <a:solidFill>
-                  <a:srgbClr val="5C5C62"/>
-                </a:solidFill>
-                <a:latin typeface="Arial"/>
-              </a:rPr>
-            </a:br>
-            <a:r>
-              <a:rPr lang="ru-RU" sz="1300" dirty="0">
-                <a:solidFill>
-                  <a:srgbClr val="5C5C62"/>
-                </a:solidFill>
-                <a:latin typeface="Arial"/>
-              </a:rPr>
-              <a:t>Связаться: </a:t>
-            </a:r>
-            <a:r>
-              <a:rPr lang="en-US" sz="1300" dirty="0">
-                <a:solidFill>
-                  <a:srgbClr val="5C5C62"/>
-                </a:solidFill>
-                <a:latin typeface="Arial"/>
-              </a:rPr>
-              <a:t>@WhatMeIsLove</a:t>
-            </a:r>
-            <a:endParaRPr lang="ru-RU" sz="1300" b="0" dirty="0">
-              <a:solidFill>
-                <a:srgbClr val="5C5C62"/>
-              </a:solidFill>
-              <a:latin typeface="Arial"/>
-            </a:endParaRPr>
+                <a:spcPts val="0"/>
+              </a:spcAft>
+            </a:pPr>
+            <a:r>
+              <a:rPr sz="1200" b="0">
+                <a:solidFill>
+                  <a:srgbClr val="5C5C62"/>
+                </a:solidFill>
+                <a:latin typeface="Arial"/>
+              </a:rPr>
+              <a:t>модулей автотестов — API, UI, TG, речь, live-call</a:t>
+            </a:r>
           </a:p>
         </p:txBody>
       </p:sp>
@@ -9475,8 +9242,8 @@
         </p:nvSpPr>
         <p:spPr>
           <a:xfrm>
-            <a:off x="6686791" y="1655053"/>
-            <a:ext cx="3657600" cy="4114800"/>
+            <a:off x="4297680" y="1554480"/>
+            <a:ext cx="3566160" cy="1143000"/>
           </a:xfrm>
           <a:prstGeom prst="roundRect">
             <a:avLst>
@@ -9509,7 +9276,6 @@
           <a:lstStyle/>
           <a:p>
             <a:pPr algn="ctr"/>
-            <a:endParaRPr/>
           </a:p>
         </p:txBody>
       </p:sp>
@@ -9521,8 +9287,8 @@
         </p:nvSpPr>
         <p:spPr>
           <a:xfrm>
-            <a:off x="6636499" y="1651278"/>
-            <a:ext cx="73152" cy="4114800"/>
+            <a:off x="4297680" y="1554480"/>
+            <a:ext cx="73152" cy="1143000"/>
           </a:xfrm>
           <a:prstGeom prst="rect">
             <a:avLst/>
@@ -9553,7 +9319,6 @@
           <a:lstStyle/>
           <a:p>
             <a:pPr algn="ctr"/>
-            <a:endParaRPr/>
           </a:p>
         </p:txBody>
       </p:sp>
@@ -9565,8 +9330,8 @@
         </p:nvSpPr>
         <p:spPr>
           <a:xfrm>
-            <a:off x="6818888" y="3874429"/>
-            <a:ext cx="651140" cy="323165"/>
+            <a:off x="4480560" y="1719072"/>
+            <a:ext cx="3246120" cy="502920"/>
           </a:xfrm>
           <a:prstGeom prst="rect">
             <a:avLst/>
@@ -9585,20 +9350,14 @@
               </a:spcAft>
             </a:pPr>
             <a:r>
-              <a:rPr lang="ru-RU" sz="1500" b="1" dirty="0">
-                <a:solidFill>
-                  <a:srgbClr val="1A1A1A"/>
-                </a:solidFill>
-                <a:latin typeface="Arial"/>
-              </a:rPr>
-              <a:t>Дана</a:t>
-            </a:r>
-            <a:endParaRPr sz="1500" b="1" dirty="0">
-              <a:solidFill>
-                <a:srgbClr val="1A1A1A"/>
-              </a:solidFill>
-              <a:latin typeface="Arial"/>
-            </a:endParaRPr>
+              <a:rPr sz="2800" b="1">
+                <a:solidFill>
+                  <a:srgbClr val="E30611"/>
+                </a:solidFill>
+                <a:latin typeface="Arial"/>
+              </a:rPr>
+              <a:t>60+</a:t>
+            </a:r>
           </a:p>
         </p:txBody>
       </p:sp>
@@ -9610,8 +9369,340 @@
         </p:nvSpPr>
         <p:spPr>
           <a:xfrm>
-            <a:off x="6818888" y="4251011"/>
-            <a:ext cx="3246120" cy="1492716"/>
+            <a:off x="4480560" y="2212848"/>
+            <a:ext cx="3246120" cy="411480"/>
+          </a:xfrm>
+          <a:prstGeom prst="rect">
+            <a:avLst/>
+          </a:prstGeom>
+          <a:noFill/>
+        </p:spPr>
+        <p:txBody>
+          <a:bodyPr wrap="none">
+            <a:spAutoFit/>
+          </a:bodyPr>
+          <a:lstStyle/>
+          <a:p>
+            <a:pPr algn="l">
+              <a:spcAft>
+                <a:spcPts val="0"/>
+              </a:spcAft>
+            </a:pPr>
+            <a:r>
+              <a:rPr sz="1200" b="0">
+                <a:solidFill>
+                  <a:srgbClr val="5C5C62"/>
+                </a:solidFill>
+                <a:latin typeface="Arial"/>
+              </a:rPr>
+              <a:t>сценариев в матрице маршрутизации</a:t>
+            </a:r>
+          </a:p>
+        </p:txBody>
+      </p:sp>
+      <p:sp>
+        <p:nvSpPr>
+          <p:cNvPr id="14" name="Rounded Rectangle 13"/>
+          <p:cNvSpPr/>
+          <p:nvPr/>
+        </p:nvSpPr>
+        <p:spPr>
+          <a:xfrm>
+            <a:off x="8092440" y="1554480"/>
+            <a:ext cx="3566160" cy="1143000"/>
+          </a:xfrm>
+          <a:prstGeom prst="roundRect">
+            <a:avLst>
+              <a:gd name="adj" fmla="val 8000"/>
+            </a:avLst>
+          </a:prstGeom>
+          <a:solidFill>
+            <a:srgbClr val="FFFFFF"/>
+          </a:solidFill>
+          <a:ln>
+            <a:noFill/>
+          </a:ln>
+        </p:spPr>
+        <p:style>
+          <a:lnRef idx="1">
+            <a:schemeClr val="accent1"/>
+          </a:lnRef>
+          <a:fillRef idx="3">
+            <a:schemeClr val="accent1"/>
+          </a:fillRef>
+          <a:effectRef idx="2">
+            <a:schemeClr val="accent1"/>
+          </a:effectRef>
+          <a:fontRef idx="minor">
+            <a:schemeClr val="lt1"/>
+          </a:fontRef>
+        </p:style>
+        <p:txBody>
+          <a:bodyPr rtlCol="0" anchor="ctr"/>
+          <a:lstStyle/>
+          <a:p>
+            <a:pPr algn="ctr"/>
+          </a:p>
+        </p:txBody>
+      </p:sp>
+      <p:sp>
+        <p:nvSpPr>
+          <p:cNvPr id="15" name="Rectangle 14"/>
+          <p:cNvSpPr/>
+          <p:nvPr/>
+        </p:nvSpPr>
+        <p:spPr>
+          <a:xfrm>
+            <a:off x="8092440" y="1554480"/>
+            <a:ext cx="73152" cy="1143000"/>
+          </a:xfrm>
+          <a:prstGeom prst="rect">
+            <a:avLst/>
+          </a:prstGeom>
+          <a:solidFill>
+            <a:srgbClr val="E30611"/>
+          </a:solidFill>
+          <a:ln>
+            <a:noFill/>
+          </a:ln>
+        </p:spPr>
+        <p:style>
+          <a:lnRef idx="1">
+            <a:schemeClr val="accent1"/>
+          </a:lnRef>
+          <a:fillRef idx="3">
+            <a:schemeClr val="accent1"/>
+          </a:fillRef>
+          <a:effectRef idx="2">
+            <a:schemeClr val="accent1"/>
+          </a:effectRef>
+          <a:fontRef idx="minor">
+            <a:schemeClr val="lt1"/>
+          </a:fontRef>
+        </p:style>
+        <p:txBody>
+          <a:bodyPr rtlCol="0" anchor="ctr"/>
+          <a:lstStyle/>
+          <a:p>
+            <a:pPr algn="ctr"/>
+          </a:p>
+        </p:txBody>
+      </p:sp>
+      <p:sp>
+        <p:nvSpPr>
+          <p:cNvPr id="16" name="TextBox 15"/>
+          <p:cNvSpPr txBox="1"/>
+          <p:nvPr/>
+        </p:nvSpPr>
+        <p:spPr>
+          <a:xfrm>
+            <a:off x="8275320" y="1719072"/>
+            <a:ext cx="3246120" cy="502920"/>
+          </a:xfrm>
+          <a:prstGeom prst="rect">
+            <a:avLst/>
+          </a:prstGeom>
+          <a:noFill/>
+        </p:spPr>
+        <p:txBody>
+          <a:bodyPr wrap="none">
+            <a:spAutoFit/>
+          </a:bodyPr>
+          <a:lstStyle/>
+          <a:p>
+            <a:pPr algn="l">
+              <a:spcAft>
+                <a:spcPts val="0"/>
+              </a:spcAft>
+            </a:pPr>
+            <a:r>
+              <a:rPr sz="2800" b="1">
+                <a:solidFill>
+                  <a:srgbClr val="E30611"/>
+                </a:solidFill>
+                <a:latin typeface="Arial"/>
+              </a:rPr>
+              <a:t>100+</a:t>
+            </a:r>
+          </a:p>
+        </p:txBody>
+      </p:sp>
+      <p:sp>
+        <p:nvSpPr>
+          <p:cNvPr id="17" name="TextBox 16"/>
+          <p:cNvSpPr txBox="1"/>
+          <p:nvPr/>
+        </p:nvSpPr>
+        <p:spPr>
+          <a:xfrm>
+            <a:off x="8275320" y="2212848"/>
+            <a:ext cx="3246120" cy="411480"/>
+          </a:xfrm>
+          <a:prstGeom prst="rect">
+            <a:avLst/>
+          </a:prstGeom>
+          <a:noFill/>
+        </p:spPr>
+        <p:txBody>
+          <a:bodyPr wrap="none">
+            <a:spAutoFit/>
+          </a:bodyPr>
+          <a:lstStyle/>
+          <a:p>
+            <a:pPr algn="l">
+              <a:spcAft>
+                <a:spcPts val="0"/>
+              </a:spcAft>
+            </a:pPr>
+            <a:r>
+              <a:rPr sz="1200" b="0">
+                <a:solidFill>
+                  <a:srgbClr val="5C5C62"/>
+                </a:solidFill>
+                <a:latin typeface="Arial"/>
+              </a:rPr>
+              <a:t>проверок offline-suite без облака</a:t>
+            </a:r>
+          </a:p>
+        </p:txBody>
+      </p:sp>
+      <p:sp>
+        <p:nvSpPr>
+          <p:cNvPr id="18" name="Rounded Rectangle 17"/>
+          <p:cNvSpPr/>
+          <p:nvPr/>
+        </p:nvSpPr>
+        <p:spPr>
+          <a:xfrm>
+            <a:off x="502920" y="2926080"/>
+            <a:ext cx="5486400" cy="2926080"/>
+          </a:xfrm>
+          <a:prstGeom prst="roundRect">
+            <a:avLst>
+              <a:gd name="adj" fmla="val 8000"/>
+            </a:avLst>
+          </a:prstGeom>
+          <a:solidFill>
+            <a:srgbClr val="FFFFFF"/>
+          </a:solidFill>
+          <a:ln>
+            <a:noFill/>
+          </a:ln>
+        </p:spPr>
+        <p:style>
+          <a:lnRef idx="1">
+            <a:schemeClr val="accent1"/>
+          </a:lnRef>
+          <a:fillRef idx="3">
+            <a:schemeClr val="accent1"/>
+          </a:fillRef>
+          <a:effectRef idx="2">
+            <a:schemeClr val="accent1"/>
+          </a:effectRef>
+          <a:fontRef idx="minor">
+            <a:schemeClr val="lt1"/>
+          </a:fontRef>
+        </p:style>
+        <p:txBody>
+          <a:bodyPr rtlCol="0" anchor="ctr"/>
+          <a:lstStyle/>
+          <a:p>
+            <a:pPr algn="ctr"/>
+          </a:p>
+        </p:txBody>
+      </p:sp>
+      <p:sp>
+        <p:nvSpPr>
+          <p:cNvPr id="19" name="Rectangle 18"/>
+          <p:cNvSpPr/>
+          <p:nvPr/>
+        </p:nvSpPr>
+        <p:spPr>
+          <a:xfrm>
+            <a:off x="502920" y="2926080"/>
+            <a:ext cx="73152" cy="2926080"/>
+          </a:xfrm>
+          <a:prstGeom prst="rect">
+            <a:avLst/>
+          </a:prstGeom>
+          <a:solidFill>
+            <a:srgbClr val="E30611"/>
+          </a:solidFill>
+          <a:ln>
+            <a:noFill/>
+          </a:ln>
+        </p:spPr>
+        <p:style>
+          <a:lnRef idx="1">
+            <a:schemeClr val="accent1"/>
+          </a:lnRef>
+          <a:fillRef idx="3">
+            <a:schemeClr val="accent1"/>
+          </a:fillRef>
+          <a:effectRef idx="2">
+            <a:schemeClr val="accent1"/>
+          </a:effectRef>
+          <a:fontRef idx="minor">
+            <a:schemeClr val="lt1"/>
+          </a:fontRef>
+        </p:style>
+        <p:txBody>
+          <a:bodyPr rtlCol="0" anchor="ctr"/>
+          <a:lstStyle/>
+          <a:p>
+            <a:pPr algn="ctr"/>
+          </a:p>
+        </p:txBody>
+      </p:sp>
+      <p:sp>
+        <p:nvSpPr>
+          <p:cNvPr id="20" name="TextBox 19"/>
+          <p:cNvSpPr txBox="1"/>
+          <p:nvPr/>
+        </p:nvSpPr>
+        <p:spPr>
+          <a:xfrm>
+            <a:off x="758952" y="3127248"/>
+            <a:ext cx="5074920" cy="365760"/>
+          </a:xfrm>
+          <a:prstGeom prst="rect">
+            <a:avLst/>
+          </a:prstGeom>
+          <a:noFill/>
+        </p:spPr>
+        <p:txBody>
+          <a:bodyPr wrap="none">
+            <a:spAutoFit/>
+          </a:bodyPr>
+          <a:lstStyle/>
+          <a:p>
+            <a:pPr algn="l">
+              <a:spcAft>
+                <a:spcPts val="0"/>
+              </a:spcAft>
+            </a:pPr>
+            <a:r>
+              <a:rPr sz="1500" b="1">
+                <a:solidFill>
+                  <a:srgbClr val="1A1A1A"/>
+                </a:solidFill>
+                <a:latin typeface="Arial"/>
+              </a:rPr>
+              <a:t>Что закрыли тестами</a:t>
+            </a:r>
+          </a:p>
+        </p:txBody>
+      </p:sp>
+      <p:sp>
+        <p:nvSpPr>
+          <p:cNvPr id="21" name="TextBox 20"/>
+          <p:cNvSpPr txBox="1"/>
+          <p:nvPr/>
+        </p:nvSpPr>
+        <p:spPr>
+          <a:xfrm>
+            <a:off x="758952" y="3520440"/>
+            <a:ext cx="5074920" cy="2148840"/>
           </a:xfrm>
           <a:prstGeom prst="rect">
             <a:avLst/>
@@ -9630,153 +9721,179 @@
               </a:spcAft>
             </a:pPr>
             <a:r>
-              <a:rPr lang="en-US" sz="1300" b="0" dirty="0">
-                <a:solidFill>
-                  <a:srgbClr val="5C5C62"/>
-                </a:solidFill>
-                <a:latin typeface="Arial"/>
-              </a:rPr>
-              <a:t>Backend &amp; </a:t>
-            </a:r>
-            <a:r>
-              <a:rPr lang="en-US" sz="1300" b="0" dirty="0" err="1">
-                <a:solidFill>
-                  <a:srgbClr val="5C5C62"/>
-                </a:solidFill>
-                <a:latin typeface="Arial"/>
-              </a:rPr>
-              <a:t>Gamedev</a:t>
-            </a:r>
-            <a:r>
-              <a:rPr lang="en-US" sz="1300" b="0" dirty="0">
-                <a:solidFill>
-                  <a:srgbClr val="5C5C62"/>
-                </a:solidFill>
-                <a:latin typeface="Arial"/>
-              </a:rPr>
-              <a:t> </a:t>
-            </a:r>
-            <a:r>
-              <a:rPr lang="ru-RU" sz="1300" b="0" dirty="0">
-                <a:solidFill>
-                  <a:srgbClr val="5C5C62"/>
-                </a:solidFill>
-                <a:latin typeface="Arial"/>
-              </a:rPr>
-              <a:t>разработчик</a:t>
-            </a:r>
-            <a:br>
-              <a:rPr lang="en-US" sz="1300" b="0" dirty="0">
-                <a:solidFill>
-                  <a:srgbClr val="5C5C62"/>
-                </a:solidFill>
-                <a:latin typeface="Arial"/>
-              </a:rPr>
-            </a:br>
-            <a:br>
-              <a:rPr lang="en-US" sz="1300" b="0" dirty="0">
-                <a:solidFill>
-                  <a:srgbClr val="5C5C62"/>
-                </a:solidFill>
-                <a:latin typeface="Arial"/>
-              </a:rPr>
-            </a:br>
-            <a:r>
-              <a:rPr lang="ru-RU" sz="1300" b="0" dirty="0">
-                <a:solidFill>
-                  <a:srgbClr val="5C5C62"/>
-                </a:solidFill>
-                <a:latin typeface="Arial"/>
-              </a:rPr>
-              <a:t>- Голос модели</a:t>
-            </a:r>
-            <a:br>
-              <a:rPr lang="ru-RU" sz="1300" b="0" dirty="0">
-                <a:solidFill>
-                  <a:srgbClr val="5C5C62"/>
-                </a:solidFill>
-                <a:latin typeface="Arial"/>
-              </a:rPr>
-            </a:br>
-            <a:r>
-              <a:rPr lang="ru-RU" sz="1300" b="0" dirty="0">
-                <a:solidFill>
-                  <a:srgbClr val="5C5C62"/>
-                </a:solidFill>
-                <a:latin typeface="Arial"/>
-              </a:rPr>
-              <a:t>- Обработка сервера</a:t>
-            </a:r>
-            <a:br>
-              <a:rPr lang="ru-RU" sz="1300" b="0" dirty="0">
-                <a:solidFill>
-                  <a:srgbClr val="5C5C62"/>
-                </a:solidFill>
-                <a:latin typeface="Arial"/>
-              </a:rPr>
-            </a:br>
-            <a:r>
-              <a:rPr lang="ru-RU" sz="1300" b="0" dirty="0">
-                <a:solidFill>
-                  <a:srgbClr val="5C5C62"/>
-                </a:solidFill>
-                <a:latin typeface="Arial"/>
-              </a:rPr>
-              <a:t>- Настройка шаблонов </a:t>
-            </a:r>
-            <a:br>
-              <a:rPr lang="en-US" sz="1300" b="0" dirty="0">
-                <a:solidFill>
-                  <a:srgbClr val="5C5C62"/>
-                </a:solidFill>
-                <a:latin typeface="Arial"/>
-              </a:rPr>
-            </a:br>
-            <a:br>
-              <a:rPr lang="en-US" sz="1300" b="0" dirty="0">
-                <a:solidFill>
-                  <a:srgbClr val="5C5C62"/>
-                </a:solidFill>
-                <a:latin typeface="Arial"/>
-              </a:rPr>
-            </a:br>
-            <a:r>
-              <a:rPr lang="ru-RU" sz="1300" b="0" dirty="0">
-                <a:solidFill>
-                  <a:srgbClr val="5C5C62"/>
-                </a:solidFill>
-                <a:latin typeface="Arial"/>
-              </a:rPr>
-              <a:t>Связаться: </a:t>
-            </a:r>
-            <a:r>
-              <a:rPr lang="en-US" sz="1300" b="0" dirty="0">
-                <a:solidFill>
-                  <a:srgbClr val="5C5C62"/>
-                </a:solidFill>
-                <a:latin typeface="Arial"/>
-              </a:rPr>
-              <a:t>@IKnowAllYourSecretss</a:t>
-            </a:r>
-            <a:endParaRPr lang="ru-RU" sz="1300" b="0" dirty="0">
-              <a:solidFill>
-                <a:srgbClr val="5C5C62"/>
-              </a:solidFill>
-              <a:latin typeface="Arial"/>
-            </a:endParaRPr>
-          </a:p>
-        </p:txBody>
-      </p:sp>
-      <p:sp>
-        <p:nvSpPr>
-          <p:cNvPr id="18" name="TextBox 17"/>
+              <a:rPr sz="1300" b="0">
+                <a:solidFill>
+                  <a:srgbClr val="5C5C62"/>
+                </a:solidFill>
+                <a:latin typeface="Arial"/>
+              </a:rPr>
+              <a:t>Контракты API, LLM, routing, шаблоны, hotline</a:t>
+            </a:r>
+          </a:p>
+          <a:p>
+            <a:pPr algn="l">
+              <a:spcAft>
+                <a:spcPts val="400"/>
+              </a:spcAft>
+            </a:pPr>
+            <a:r>
+              <a:rPr sz="1300" b="0">
+                <a:solidFill>
+                  <a:srgbClr val="5C5C62"/>
+                </a:solidFill>
+                <a:latin typeface="Arial"/>
+              </a:rPr>
+              <a:t>Live-call: VAD, barge-in, многоходовый диалог</a:t>
+            </a:r>
+          </a:p>
+          <a:p>
+            <a:pPr algn="l">
+              <a:spcAft>
+                <a:spcPts val="400"/>
+              </a:spcAft>
+            </a:pPr>
+            <a:r>
+              <a:rPr sz="1300" b="0">
+                <a:solidFill>
+                  <a:srgbClr val="5C5C62"/>
+                </a:solidFill>
+                <a:latin typeface="Arial"/>
+              </a:rPr>
+              <a:t>Flet UI + Telegram-дашборд + изоляция линий</a:t>
+            </a:r>
+          </a:p>
+          <a:p>
+            <a:pPr algn="l">
+              <a:spcAft>
+                <a:spcPts val="400"/>
+              </a:spcAft>
+            </a:pPr>
+            <a:r>
+              <a:rPr sz="1300" b="0">
+                <a:solidFill>
+                  <a:srgbClr val="5C5C62"/>
+                </a:solidFill>
+                <a:latin typeface="Arial"/>
+              </a:rPr>
+              <a:t>Fallback: Yandex недоступен → Whisper / edge-tts</a:t>
+            </a:r>
+          </a:p>
+          <a:p>
+            <a:pPr algn="l">
+              <a:spcAft>
+                <a:spcPts val="400"/>
+              </a:spcAft>
+            </a:pPr>
+            <a:r>
+              <a:rPr sz="1300" b="0">
+                <a:solidFill>
+                  <a:srgbClr val="5C5C62"/>
+                </a:solidFill>
+                <a:latin typeface="Arial"/>
+              </a:rPr>
+              <a:t>Аналитика: /calls/stats, critical / intent / action</a:t>
+            </a:r>
+          </a:p>
+        </p:txBody>
+      </p:sp>
+      <p:sp>
+        <p:nvSpPr>
+          <p:cNvPr id="22" name="Rounded Rectangle 21"/>
+          <p:cNvSpPr/>
+          <p:nvPr/>
+        </p:nvSpPr>
+        <p:spPr>
+          <a:xfrm>
+            <a:off x="6263640" y="2926080"/>
+            <a:ext cx="5394960" cy="2926080"/>
+          </a:xfrm>
+          <a:prstGeom prst="roundRect">
+            <a:avLst>
+              <a:gd name="adj" fmla="val 8000"/>
+            </a:avLst>
+          </a:prstGeom>
+          <a:solidFill>
+            <a:srgbClr val="FFFFFF"/>
+          </a:solidFill>
+          <a:ln>
+            <a:noFill/>
+          </a:ln>
+        </p:spPr>
+        <p:style>
+          <a:lnRef idx="1">
+            <a:schemeClr val="accent1"/>
+          </a:lnRef>
+          <a:fillRef idx="3">
+            <a:schemeClr val="accent1"/>
+          </a:fillRef>
+          <a:effectRef idx="2">
+            <a:schemeClr val="accent1"/>
+          </a:effectRef>
+          <a:fontRef idx="minor">
+            <a:schemeClr val="lt1"/>
+          </a:fontRef>
+        </p:style>
+        <p:txBody>
+          <a:bodyPr rtlCol="0" anchor="ctr"/>
+          <a:lstStyle/>
+          <a:p>
+            <a:pPr algn="ctr"/>
+          </a:p>
+        </p:txBody>
+      </p:sp>
+      <p:sp>
+        <p:nvSpPr>
+          <p:cNvPr id="23" name="Rectangle 22"/>
+          <p:cNvSpPr/>
+          <p:nvPr/>
+        </p:nvSpPr>
+        <p:spPr>
+          <a:xfrm>
+            <a:off x="6263640" y="2926080"/>
+            <a:ext cx="73152" cy="2926080"/>
+          </a:xfrm>
+          <a:prstGeom prst="rect">
+            <a:avLst/>
+          </a:prstGeom>
+          <a:solidFill>
+            <a:srgbClr val="E30611"/>
+          </a:solidFill>
+          <a:ln>
+            <a:noFill/>
+          </a:ln>
+        </p:spPr>
+        <p:style>
+          <a:lnRef idx="1">
+            <a:schemeClr val="accent1"/>
+          </a:lnRef>
+          <a:fillRef idx="3">
+            <a:schemeClr val="accent1"/>
+          </a:fillRef>
+          <a:effectRef idx="2">
+            <a:schemeClr val="accent1"/>
+          </a:effectRef>
+          <a:fontRef idx="minor">
+            <a:schemeClr val="lt1"/>
+          </a:fontRef>
+        </p:style>
+        <p:txBody>
+          <a:bodyPr rtlCol="0" anchor="ctr"/>
+          <a:lstStyle/>
+          <a:p>
+            <a:pPr algn="ctr"/>
+          </a:p>
+        </p:txBody>
+      </p:sp>
+      <p:sp>
+        <p:nvSpPr>
+          <p:cNvPr id="24" name="TextBox 23"/>
           <p:cNvSpPr txBox="1"/>
           <p:nvPr/>
         </p:nvSpPr>
         <p:spPr>
           <a:xfrm>
-            <a:off x="502920" y="6492240"/>
-            <a:ext cx="9144000" cy="256032"/>
+            <a:off x="6519672" y="3127248"/>
+            <a:ext cx="4983480" cy="365760"/>
           </a:xfrm>
           <a:prstGeom prst="rect">
             <a:avLst/>
@@ -9795,99 +9912,130 @@
               </a:spcAft>
             </a:pPr>
             <a:r>
-              <a:rPr sz="1000" b="0" dirty="0">
-                <a:solidFill>
-                  <a:srgbClr val="8A8A90"/>
-                </a:solidFill>
-                <a:latin typeface="Arial"/>
-              </a:rPr>
-              <a:t>ИИ-</a:t>
-            </a:r>
-            <a:r>
-              <a:rPr sz="1000" b="0" dirty="0" err="1">
-                <a:solidFill>
-                  <a:srgbClr val="8A8A90"/>
-                </a:solidFill>
-                <a:latin typeface="Arial"/>
-              </a:rPr>
-              <a:t>секретарь</a:t>
-            </a:r>
-            <a:r>
-              <a:rPr sz="1000" b="0" dirty="0">
-                <a:solidFill>
-                  <a:srgbClr val="8A8A90"/>
-                </a:solidFill>
-                <a:latin typeface="Arial"/>
-              </a:rPr>
-              <a:t> </a:t>
-            </a:r>
-            <a:r>
-              <a:rPr sz="1000" b="0" dirty="0" err="1">
-                <a:solidFill>
-                  <a:srgbClr val="8A8A90"/>
-                </a:solidFill>
-                <a:latin typeface="Arial"/>
-              </a:rPr>
-              <a:t>входящих</a:t>
-            </a:r>
-            <a:r>
-              <a:rPr sz="1000" b="0" dirty="0">
-                <a:solidFill>
-                  <a:srgbClr val="8A8A90"/>
-                </a:solidFill>
-                <a:latin typeface="Arial"/>
-              </a:rPr>
-              <a:t> · </a:t>
-            </a:r>
-            <a:r>
-              <a:rPr sz="1000" b="0" dirty="0" err="1">
-                <a:solidFill>
-                  <a:srgbClr val="8A8A90"/>
-                </a:solidFill>
-                <a:latin typeface="Arial"/>
-              </a:rPr>
-              <a:t>прототип</a:t>
-            </a:r>
-            <a:r>
-              <a:rPr sz="1000" b="0" dirty="0">
-                <a:solidFill>
-                  <a:srgbClr val="8A8A90"/>
-                </a:solidFill>
-                <a:latin typeface="Arial"/>
-              </a:rPr>
-              <a:t> </a:t>
-            </a:r>
-            <a:r>
-              <a:rPr sz="1000" b="0" dirty="0" err="1">
-                <a:solidFill>
-                  <a:srgbClr val="8A8A90"/>
-                </a:solidFill>
-                <a:latin typeface="Arial"/>
-              </a:rPr>
-              <a:t>для</a:t>
-            </a:r>
-            <a:r>
-              <a:rPr sz="1000" b="0" dirty="0">
-                <a:solidFill>
-                  <a:srgbClr val="8A8A90"/>
-                </a:solidFill>
-                <a:latin typeface="Arial"/>
-              </a:rPr>
-              <a:t> МТС</a:t>
-            </a:r>
-          </a:p>
-        </p:txBody>
-      </p:sp>
-      <p:sp>
-        <p:nvSpPr>
-          <p:cNvPr id="19" name="TextBox 18"/>
+              <a:rPr sz="1500" b="1">
+                <a:solidFill>
+                  <a:srgbClr val="1A1A1A"/>
+                </a:solidFill>
+                <a:latin typeface="Arial"/>
+              </a:rPr>
+              <a:t>Полевые прогоны</a:t>
+            </a:r>
+          </a:p>
+        </p:txBody>
+      </p:sp>
+      <p:sp>
+        <p:nvSpPr>
+          <p:cNvPr id="25" name="TextBox 24"/>
           <p:cNvSpPr txBox="1"/>
           <p:nvPr/>
         </p:nvSpPr>
         <p:spPr>
           <a:xfrm>
-            <a:off x="11526203" y="6492240"/>
-            <a:ext cx="360997" cy="246221"/>
+            <a:off x="6519672" y="3520440"/>
+            <a:ext cx="4983480" cy="2148840"/>
+          </a:xfrm>
+          <a:prstGeom prst="rect">
+            <a:avLst/>
+          </a:prstGeom>
+          <a:noFill/>
+        </p:spPr>
+        <p:txBody>
+          <a:bodyPr wrap="square">
+            <a:spAutoFit/>
+          </a:bodyPr>
+          <a:lstStyle/>
+          <a:p>
+            <a:pPr algn="l">
+              <a:spcAft>
+                <a:spcPts val="400"/>
+              </a:spcAft>
+            </a:pPr>
+            <a:r>
+              <a:rPr sz="1300" b="0">
+                <a:solidFill>
+                  <a:srgbClr val="5C5C62"/>
+                </a:solidFill>
+                <a:latin typeface="Arial"/>
+              </a:rPr>
+              <a:t>Шумное помещение: фон, эхо, чужая речь рядом</a:t>
+            </a:r>
+          </a:p>
+          <a:p>
+            <a:pPr algn="l">
+              <a:spcAft>
+                <a:spcPts val="400"/>
+              </a:spcAft>
+            </a:pPr>
+            <a:r>
+              <a:rPr sz="1300" b="0">
+                <a:solidFill>
+                  <a:srgbClr val="5C5C62"/>
+                </a:solidFill>
+                <a:latin typeface="Arial"/>
+              </a:rPr>
+              <a:t>Разные голоса, темп и громкость абонента</a:t>
+            </a:r>
+          </a:p>
+          <a:p>
+            <a:pPr algn="l">
+              <a:spcAft>
+                <a:spcPts val="400"/>
+              </a:spcAft>
+            </a:pPr>
+            <a:r>
+              <a:rPr sz="1300" b="0">
+                <a:solidFill>
+                  <a:srgbClr val="5C5C62"/>
+                </a:solidFill>
+                <a:latin typeface="Arial"/>
+              </a:rPr>
+              <a:t>Перебивание агента на полуслове (barge-in)</a:t>
+            </a:r>
+          </a:p>
+          <a:p>
+            <a:pPr algn="l">
+              <a:spcAft>
+                <a:spcPts val="400"/>
+              </a:spcAft>
+            </a:pPr>
+            <a:r>
+              <a:rPr sz="1300" b="0">
+                <a:solidFill>
+                  <a:srgbClr val="5C5C62"/>
+                </a:solidFill>
+                <a:latin typeface="Arial"/>
+              </a:rPr>
+              <a:t>Сеть с VPN / без Yandex — запасной STT/TTS</a:t>
+            </a:r>
+          </a:p>
+          <a:p>
+            <a:pPr algn="l">
+              <a:spcAft>
+                <a:spcPts val="400"/>
+              </a:spcAft>
+            </a:pPr>
+            <a:r>
+              <a:rPr sz="1300" b="0">
+                <a:solidFill>
+                  <a:srgbClr val="5C5C62"/>
+                </a:solidFill>
+                <a:latin typeface="Arial"/>
+              </a:rPr>
+              <a:t>E2E: приложение → звонок → история → правка</a:t>
+            </a:r>
+          </a:p>
+        </p:txBody>
+      </p:sp>
+      <p:sp>
+        <p:nvSpPr>
+          <p:cNvPr id="26" name="TextBox 25"/>
+          <p:cNvSpPr txBox="1"/>
+          <p:nvPr/>
+        </p:nvSpPr>
+        <p:spPr>
+          <a:xfrm>
+            <a:off x="502920" y="6492240"/>
+            <a:ext cx="9144000" cy="256032"/>
           </a:xfrm>
           <a:prstGeom prst="rect">
             <a:avLst/>
@@ -9900,130 +10048,63 @@
           </a:bodyPr>
           <a:lstStyle/>
           <a:p>
+            <a:pPr algn="l">
+              <a:spcAft>
+                <a:spcPts val="0"/>
+              </a:spcAft>
+            </a:pPr>
+            <a:r>
+              <a:rPr sz="1000" b="0">
+                <a:solidFill>
+                  <a:srgbClr val="8A8A90"/>
+                </a:solidFill>
+                <a:latin typeface="Arial"/>
+              </a:rPr>
+              <a:t>ИИ-секретарь входящих · прототип для МТС</a:t>
+            </a:r>
+          </a:p>
+        </p:txBody>
+      </p:sp>
+      <p:sp>
+        <p:nvSpPr>
+          <p:cNvPr id="27" name="TextBox 26"/>
+          <p:cNvSpPr txBox="1"/>
+          <p:nvPr/>
+        </p:nvSpPr>
+        <p:spPr>
+          <a:xfrm>
+            <a:off x="11155680" y="6492240"/>
+            <a:ext cx="731520" cy="256032"/>
+          </a:xfrm>
+          <a:prstGeom prst="rect">
+            <a:avLst/>
+          </a:prstGeom>
+          <a:noFill/>
+        </p:spPr>
+        <p:txBody>
+          <a:bodyPr wrap="none">
+            <a:spAutoFit/>
+          </a:bodyPr>
+          <a:lstStyle/>
+          <a:p>
             <a:pPr algn="r">
               <a:spcAft>
                 <a:spcPts val="0"/>
               </a:spcAft>
             </a:pPr>
             <a:r>
-              <a:rPr lang="en-US" sz="1000" dirty="0">
+              <a:rPr sz="1000">
                 <a:solidFill>
                   <a:srgbClr val="8A8A90"/>
                 </a:solidFill>
                 <a:latin typeface="Arial"/>
               </a:rPr>
-              <a:t>7</a:t>
-            </a:r>
-            <a:r>
-              <a:rPr sz="1000" b="0" dirty="0">
-                <a:solidFill>
-                  <a:srgbClr val="8A8A90"/>
-                </a:solidFill>
-                <a:latin typeface="Arial"/>
-              </a:rPr>
-              <a:t>/</a:t>
-            </a:r>
-            <a:r>
-              <a:rPr lang="en-US" sz="1000" b="0" dirty="0">
-                <a:solidFill>
-                  <a:srgbClr val="8A8A90"/>
-                </a:solidFill>
-                <a:latin typeface="Arial"/>
-              </a:rPr>
-              <a:t>8</a:t>
-            </a:r>
-            <a:endParaRPr sz="1000" b="0" dirty="0">
-              <a:solidFill>
-                <a:srgbClr val="8A8A90"/>
-              </a:solidFill>
-              <a:latin typeface="Arial"/>
-            </a:endParaRPr>
-          </a:p>
-        </p:txBody>
-      </p:sp>
-      <p:pic>
-        <p:nvPicPr>
-          <p:cNvPr id="20" name="Рисунок 19">
-            <a:extLst>
-              <a:ext uri="{FF2B5EF4-FFF2-40B4-BE49-F238E27FC236}">
-                <a16:creationId xmlns:a16="http://schemas.microsoft.com/office/drawing/2014/main" id="{121F706B-0E09-42B7-ABB3-344146453099}"/>
-              </a:ext>
-            </a:extLst>
-          </p:cNvPr>
-          <p:cNvPicPr>
-            <a:picLocks noChangeAspect="1"/>
-          </p:cNvPicPr>
-          <p:nvPr/>
-        </p:nvPicPr>
-        <p:blipFill>
-          <a:blip r:embed="rId2"/>
-          <a:stretch>
-            <a:fillRect/>
-          </a:stretch>
-        </p:blipFill>
-        <p:spPr>
-          <a:xfrm>
-            <a:off x="7484346" y="1874520"/>
-            <a:ext cx="2161492" cy="2161492"/>
-          </a:xfrm>
-          <a:prstGeom prst="ellipse">
-            <a:avLst/>
-          </a:prstGeom>
-        </p:spPr>
-      </p:pic>
-      <p:pic>
-        <p:nvPicPr>
-          <p:cNvPr id="1026" name="Picture 2" descr="profile-avatar">
-            <a:extLst>
-              <a:ext uri="{FF2B5EF4-FFF2-40B4-BE49-F238E27FC236}">
-                <a16:creationId xmlns:a16="http://schemas.microsoft.com/office/drawing/2014/main" id="{C581D9DE-73EC-4579-A095-6CEEABFB8138}"/>
-              </a:ext>
-            </a:extLst>
-          </p:cNvPr>
-          <p:cNvPicPr>
-            <a:picLocks noChangeAspect="1" noChangeArrowheads="1"/>
-          </p:cNvPicPr>
-          <p:nvPr/>
-        </p:nvPicPr>
-        <p:blipFill>
-          <a:blip r:embed="rId3">
-            <a:extLst>
-              <a:ext uri="{28A0092B-C50C-407E-A947-70E740481C1C}">
-                <a14:useLocalDpi xmlns:a14="http://schemas.microsoft.com/office/drawing/2010/main" val="0"/>
-              </a:ext>
-            </a:extLst>
-          </a:blip>
-          <a:srcRect/>
-          <a:stretch>
-            <a:fillRect/>
-          </a:stretch>
-        </p:blipFill>
-        <p:spPr bwMode="auto">
-          <a:xfrm>
-            <a:off x="2570923" y="1898614"/>
-            <a:ext cx="2210972" cy="2210972"/>
-          </a:xfrm>
-          <a:prstGeom prst="ellipse">
-            <a:avLst/>
-          </a:prstGeom>
-          <a:noFill/>
-          <a:extLst>
-            <a:ext uri="{909E8E84-426E-40DD-AFC4-6F175D3DCCD1}">
-              <a14:hiddenFill xmlns:a14="http://schemas.microsoft.com/office/drawing/2010/main">
-                <a:solidFill>
-                  <a:srgbClr val="FFFFFF"/>
-                </a:solidFill>
-              </a14:hiddenFill>
-            </a:ext>
-          </a:extLst>
-        </p:spPr>
-      </p:pic>
+              <a:t>7/9</a:t>
+            </a:r>
+          </a:p>
+        </p:txBody>
+      </p:sp>
     </p:spTree>
-    <p:extLst>
-      <p:ext uri="{BB962C8B-B14F-4D97-AF65-F5344CB8AC3E}">
-        <p14:creationId xmlns:p14="http://schemas.microsoft.com/office/powerpoint/2010/main" val="4257334031"/>
-      </p:ext>
-    </p:extLst>
   </p:cSld>
   <p:clrMapOvr>
     <a:masterClrMapping/>
@@ -10182,7 +10263,7 @@
                 </a:solidFill>
                 <a:latin typeface="Arial"/>
               </a:rPr>
-              <a:t>Вопросы и ответы</a:t>
+              <a:t>Кто мы?</a:t>
             </a:r>
             <a:endParaRPr sz="3000" b="1" dirty="0">
               <a:solidFill>
@@ -10202,7 +10283,7 @@
         <p:spPr>
           <a:xfrm>
             <a:off x="502920" y="1097280"/>
-            <a:ext cx="3908891" cy="323165"/>
+            <a:ext cx="3349122" cy="323165"/>
           </a:xfrm>
           <a:prstGeom prst="rect">
             <a:avLst/>
@@ -10227,7 +10308,7 @@
                 </a:solidFill>
                 <a:latin typeface="Arial"/>
               </a:rPr>
-              <a:t>Буду рад ответить на возникшие вопросы</a:t>
+              <a:t>Великолепная команда – Два нуля!</a:t>
             </a:r>
             <a:endParaRPr sz="1500" b="0" dirty="0">
               <a:solidFill>
@@ -10240,14 +10321,104 @@
       </p:sp>
       <p:sp>
         <p:nvSpPr>
-          <p:cNvPr id="18" name="TextBox 17"/>
+          <p:cNvPr id="6" name="Rounded Rectangle 5"/>
+          <p:cNvSpPr/>
+          <p:nvPr/>
+        </p:nvSpPr>
+        <p:spPr>
+          <a:xfrm>
+            <a:off x="1847609" y="1645920"/>
+            <a:ext cx="3657600" cy="4114800"/>
+          </a:xfrm>
+          <a:prstGeom prst="roundRect">
+            <a:avLst>
+              <a:gd name="adj" fmla="val 8000"/>
+            </a:avLst>
+          </a:prstGeom>
+          <a:solidFill>
+            <a:srgbClr val="FFFFFF"/>
+          </a:solidFill>
+          <a:ln>
+            <a:noFill/>
+          </a:ln>
+        </p:spPr>
+        <p:style>
+          <a:lnRef idx="1">
+            <a:schemeClr val="accent1"/>
+          </a:lnRef>
+          <a:fillRef idx="3">
+            <a:schemeClr val="accent1"/>
+          </a:fillRef>
+          <a:effectRef idx="2">
+            <a:schemeClr val="accent1"/>
+          </a:effectRef>
+          <a:fontRef idx="minor">
+            <a:schemeClr val="lt1"/>
+          </a:fontRef>
+        </p:style>
+        <p:txBody>
+          <a:bodyPr rtlCol="0" anchor="ctr"/>
+          <a:lstStyle/>
+          <a:p>
+            <a:pPr algn="ctr"/>
+            <a:endParaRPr/>
+          </a:p>
+        </p:txBody>
+      </p:sp>
+      <p:sp>
+        <p:nvSpPr>
+          <p:cNvPr id="7" name="Rectangle 6"/>
+          <p:cNvSpPr/>
+          <p:nvPr/>
+        </p:nvSpPr>
+        <p:spPr>
+          <a:xfrm>
+            <a:off x="1797317" y="1651278"/>
+            <a:ext cx="73152" cy="4114800"/>
+          </a:xfrm>
+          <a:prstGeom prst="rect">
+            <a:avLst/>
+          </a:prstGeom>
+          <a:solidFill>
+            <a:srgbClr val="E30611"/>
+          </a:solidFill>
+          <a:ln>
+            <a:noFill/>
+          </a:ln>
+        </p:spPr>
+        <p:style>
+          <a:lnRef idx="1">
+            <a:schemeClr val="accent1"/>
+          </a:lnRef>
+          <a:fillRef idx="3">
+            <a:schemeClr val="accent1"/>
+          </a:fillRef>
+          <a:effectRef idx="2">
+            <a:schemeClr val="accent1"/>
+          </a:effectRef>
+          <a:fontRef idx="minor">
+            <a:schemeClr val="lt1"/>
+          </a:fontRef>
+        </p:style>
+        <p:txBody>
+          <a:bodyPr rtlCol="0" anchor="ctr"/>
+          <a:lstStyle/>
+          <a:p>
+            <a:pPr algn="ctr"/>
+            <a:endParaRPr/>
+          </a:p>
+        </p:txBody>
+      </p:sp>
+      <p:sp>
+        <p:nvSpPr>
+          <p:cNvPr id="8" name="TextBox 7"/>
           <p:cNvSpPr txBox="1"/>
           <p:nvPr/>
         </p:nvSpPr>
         <p:spPr>
           <a:xfrm>
-            <a:off x="502920" y="6492240"/>
-            <a:ext cx="9144000" cy="256032"/>
+            <a:off x="1901992" y="3874429"/>
+            <a:ext cx="675185" cy="323165"/>
           </a:xfrm>
           <a:prstGeom prst="rect">
             <a:avLst/>
@@ -10266,99 +10437,296 @@
               </a:spcAft>
             </a:pPr>
             <a:r>
-              <a:rPr sz="1000" b="0" dirty="0">
-                <a:solidFill>
-                  <a:srgbClr val="8A8A90"/>
-                </a:solidFill>
-                <a:latin typeface="Arial"/>
-              </a:rPr>
-              <a:t>ИИ-</a:t>
-            </a:r>
-            <a:r>
-              <a:rPr sz="1000" b="0" dirty="0" err="1">
-                <a:solidFill>
-                  <a:srgbClr val="8A8A90"/>
-                </a:solidFill>
-                <a:latin typeface="Arial"/>
-              </a:rPr>
-              <a:t>секретарь</a:t>
-            </a:r>
-            <a:r>
-              <a:rPr sz="1000" b="0" dirty="0">
-                <a:solidFill>
-                  <a:srgbClr val="8A8A90"/>
+              <a:rPr lang="ru-RU" sz="1500" b="1" dirty="0">
+                <a:solidFill>
+                  <a:srgbClr val="1A1A1A"/>
+                </a:solidFill>
+                <a:latin typeface="Arial"/>
+              </a:rPr>
+              <a:t>Влад</a:t>
+            </a:r>
+            <a:endParaRPr sz="1500" b="1" dirty="0">
+              <a:solidFill>
+                <a:srgbClr val="1A1A1A"/>
+              </a:solidFill>
+              <a:latin typeface="Arial"/>
+            </a:endParaRPr>
+          </a:p>
+        </p:txBody>
+      </p:sp>
+      <p:sp>
+        <p:nvSpPr>
+          <p:cNvPr id="9" name="TextBox 8"/>
+          <p:cNvSpPr txBox="1"/>
+          <p:nvPr/>
+        </p:nvSpPr>
+        <p:spPr>
+          <a:xfrm>
+            <a:off x="1932485" y="4236216"/>
+            <a:ext cx="3246120" cy="1544012"/>
+          </a:xfrm>
+          <a:prstGeom prst="rect">
+            <a:avLst/>
+          </a:prstGeom>
+          <a:noFill/>
+        </p:spPr>
+        <p:txBody>
+          <a:bodyPr wrap="square">
+            <a:spAutoFit/>
+          </a:bodyPr>
+          <a:lstStyle/>
+          <a:p>
+            <a:pPr algn="l">
+              <a:spcAft>
+                <a:spcPts val="400"/>
+              </a:spcAft>
+            </a:pPr>
+            <a:r>
+              <a:rPr lang="en-US" sz="1300" dirty="0">
+                <a:solidFill>
+                  <a:srgbClr val="5C5C62"/>
+                </a:solidFill>
+                <a:latin typeface="Arial"/>
+              </a:rPr>
+              <a:t>Backend QA Engineer</a:t>
+            </a:r>
+            <a:br>
+              <a:rPr lang="ru-RU" sz="1300" dirty="0">
+                <a:solidFill>
+                  <a:srgbClr val="5C5C62"/>
+                </a:solidFill>
+                <a:latin typeface="Arial"/>
+              </a:rPr>
+            </a:br>
+            <a:br>
+              <a:rPr lang="ru-RU" sz="1300" dirty="0">
+                <a:solidFill>
+                  <a:srgbClr val="5C5C62"/>
+                </a:solidFill>
+                <a:latin typeface="Arial"/>
+              </a:rPr>
+            </a:br>
+            <a:r>
+              <a:rPr lang="ru-RU" sz="1300" dirty="0">
+                <a:solidFill>
+                  <a:srgbClr val="5C5C62"/>
+                </a:solidFill>
+                <a:latin typeface="Arial"/>
+              </a:rPr>
+              <a:t>- Вид приложения</a:t>
+            </a:r>
+            <a:br>
+              <a:rPr lang="ru-RU" sz="1300" dirty="0">
+                <a:solidFill>
+                  <a:srgbClr val="5C5C62"/>
+                </a:solidFill>
+                <a:latin typeface="Arial"/>
+              </a:rPr>
+            </a:br>
+            <a:r>
+              <a:rPr lang="ru-RU" sz="1300" dirty="0">
+                <a:solidFill>
+                  <a:srgbClr val="5C5C62"/>
+                </a:solidFill>
+                <a:latin typeface="Arial"/>
+              </a:rPr>
+              <a:t>- </a:t>
+            </a:r>
+            <a:r>
+              <a:rPr lang="en-US" sz="1300" dirty="0" err="1">
+                <a:solidFill>
+                  <a:srgbClr val="5C5C62"/>
+                </a:solidFill>
+                <a:latin typeface="Arial"/>
+              </a:rPr>
+              <a:t>Tg</a:t>
+            </a:r>
+            <a:r>
+              <a:rPr lang="en-US" sz="1300" dirty="0">
+                <a:solidFill>
+                  <a:srgbClr val="5C5C62"/>
+                </a:solidFill>
+                <a:latin typeface="Arial"/>
+              </a:rPr>
+              <a:t>-</a:t>
+            </a:r>
+            <a:r>
+              <a:rPr lang="ru-RU" sz="1300" dirty="0">
+                <a:solidFill>
+                  <a:srgbClr val="5C5C62"/>
+                </a:solidFill>
+                <a:latin typeface="Arial"/>
+              </a:rPr>
+              <a:t>бот</a:t>
+            </a:r>
+          </a:p>
+          <a:p>
+            <a:pPr algn="l">
+              <a:spcAft>
+                <a:spcPts val="400"/>
+              </a:spcAft>
+            </a:pPr>
+            <a:r>
+              <a:rPr lang="ru-RU" sz="1300" b="0" dirty="0">
+                <a:solidFill>
+                  <a:srgbClr val="5C5C62"/>
+                </a:solidFill>
+                <a:latin typeface="Arial"/>
+              </a:rPr>
+              <a:t>- Безопасность</a:t>
+            </a:r>
+            <a:br>
+              <a:rPr lang="ru-RU" sz="1300" b="0" dirty="0">
+                <a:solidFill>
+                  <a:srgbClr val="5C5C62"/>
+                </a:solidFill>
+                <a:latin typeface="Arial"/>
+              </a:rPr>
+            </a:br>
+            <a:r>
+              <a:rPr lang="ru-RU" sz="1300" b="0" dirty="0">
+                <a:solidFill>
+                  <a:srgbClr val="5C5C62"/>
                 </a:solidFill>
                 <a:latin typeface="Arial"/>
               </a:rPr>
               <a:t> </a:t>
             </a:r>
-            <a:r>
-              <a:rPr sz="1000" b="0" dirty="0" err="1">
-                <a:solidFill>
-                  <a:srgbClr val="8A8A90"/>
-                </a:solidFill>
-                <a:latin typeface="Arial"/>
-              </a:rPr>
-              <a:t>входящих</a:t>
-            </a:r>
-            <a:r>
-              <a:rPr sz="1000" b="0" dirty="0">
-                <a:solidFill>
-                  <a:srgbClr val="8A8A90"/>
-                </a:solidFill>
-                <a:latin typeface="Arial"/>
-              </a:rPr>
-              <a:t> · </a:t>
-            </a:r>
-            <a:r>
-              <a:rPr sz="1000" b="0" dirty="0" err="1">
-                <a:solidFill>
-                  <a:srgbClr val="8A8A90"/>
-                </a:solidFill>
-                <a:latin typeface="Arial"/>
-              </a:rPr>
-              <a:t>прототип</a:t>
-            </a:r>
-            <a:r>
-              <a:rPr sz="1000" b="0" dirty="0">
-                <a:solidFill>
-                  <a:srgbClr val="8A8A90"/>
-                </a:solidFill>
-                <a:latin typeface="Arial"/>
-              </a:rPr>
-              <a:t> </a:t>
-            </a:r>
-            <a:r>
-              <a:rPr sz="1000" b="0" dirty="0" err="1">
-                <a:solidFill>
-                  <a:srgbClr val="8A8A90"/>
-                </a:solidFill>
-                <a:latin typeface="Arial"/>
-              </a:rPr>
-              <a:t>для</a:t>
-            </a:r>
-            <a:r>
-              <a:rPr sz="1000" b="0" dirty="0">
-                <a:solidFill>
-                  <a:srgbClr val="8A8A90"/>
-                </a:solidFill>
-                <a:latin typeface="Arial"/>
-              </a:rPr>
-              <a:t> МТС</a:t>
-            </a:r>
-          </a:p>
-        </p:txBody>
-      </p:sp>
-      <p:sp>
-        <p:nvSpPr>
-          <p:cNvPr id="19" name="TextBox 18"/>
+            <a:br>
+              <a:rPr lang="ru-RU" sz="1300" dirty="0">
+                <a:solidFill>
+                  <a:srgbClr val="5C5C62"/>
+                </a:solidFill>
+                <a:latin typeface="Arial"/>
+              </a:rPr>
+            </a:br>
+            <a:r>
+              <a:rPr lang="ru-RU" sz="1300" dirty="0">
+                <a:solidFill>
+                  <a:srgbClr val="5C5C62"/>
+                </a:solidFill>
+                <a:latin typeface="Arial"/>
+              </a:rPr>
+              <a:t>Связаться: </a:t>
+            </a:r>
+            <a:r>
+              <a:rPr lang="en-US" sz="1300" dirty="0">
+                <a:solidFill>
+                  <a:srgbClr val="5C5C62"/>
+                </a:solidFill>
+                <a:latin typeface="Arial"/>
+              </a:rPr>
+              <a:t>@WhatMeIsLove</a:t>
+            </a:r>
+            <a:endParaRPr lang="ru-RU" sz="1300" b="0" dirty="0">
+              <a:solidFill>
+                <a:srgbClr val="5C5C62"/>
+              </a:solidFill>
+              <a:latin typeface="Arial"/>
+            </a:endParaRPr>
+          </a:p>
+        </p:txBody>
+      </p:sp>
+      <p:sp>
+        <p:nvSpPr>
+          <p:cNvPr id="10" name="Rounded Rectangle 9"/>
+          <p:cNvSpPr/>
+          <p:nvPr/>
+        </p:nvSpPr>
+        <p:spPr>
+          <a:xfrm>
+            <a:off x="6686791" y="1655053"/>
+            <a:ext cx="3657600" cy="4114800"/>
+          </a:xfrm>
+          <a:prstGeom prst="roundRect">
+            <a:avLst>
+              <a:gd name="adj" fmla="val 8000"/>
+            </a:avLst>
+          </a:prstGeom>
+          <a:solidFill>
+            <a:srgbClr val="FFFFFF"/>
+          </a:solidFill>
+          <a:ln>
+            <a:noFill/>
+          </a:ln>
+        </p:spPr>
+        <p:style>
+          <a:lnRef idx="1">
+            <a:schemeClr val="accent1"/>
+          </a:lnRef>
+          <a:fillRef idx="3">
+            <a:schemeClr val="accent1"/>
+          </a:fillRef>
+          <a:effectRef idx="2">
+            <a:schemeClr val="accent1"/>
+          </a:effectRef>
+          <a:fontRef idx="minor">
+            <a:schemeClr val="lt1"/>
+          </a:fontRef>
+        </p:style>
+        <p:txBody>
+          <a:bodyPr rtlCol="0" anchor="ctr"/>
+          <a:lstStyle/>
+          <a:p>
+            <a:pPr algn="ctr"/>
+            <a:endParaRPr/>
+          </a:p>
+        </p:txBody>
+      </p:sp>
+      <p:sp>
+        <p:nvSpPr>
+          <p:cNvPr id="11" name="Rectangle 10"/>
+          <p:cNvSpPr/>
+          <p:nvPr/>
+        </p:nvSpPr>
+        <p:spPr>
+          <a:xfrm>
+            <a:off x="6636499" y="1651278"/>
+            <a:ext cx="73152" cy="4114800"/>
+          </a:xfrm>
+          <a:prstGeom prst="rect">
+            <a:avLst/>
+          </a:prstGeom>
+          <a:solidFill>
+            <a:srgbClr val="E30611"/>
+          </a:solidFill>
+          <a:ln>
+            <a:noFill/>
+          </a:ln>
+        </p:spPr>
+        <p:style>
+          <a:lnRef idx="1">
+            <a:schemeClr val="accent1"/>
+          </a:lnRef>
+          <a:fillRef idx="3">
+            <a:schemeClr val="accent1"/>
+          </a:fillRef>
+          <a:effectRef idx="2">
+            <a:schemeClr val="accent1"/>
+          </a:effectRef>
+          <a:fontRef idx="minor">
+            <a:schemeClr val="lt1"/>
+          </a:fontRef>
+        </p:style>
+        <p:txBody>
+          <a:bodyPr rtlCol="0" anchor="ctr"/>
+          <a:lstStyle/>
+          <a:p>
+            <a:pPr algn="ctr"/>
+            <a:endParaRPr/>
+          </a:p>
+        </p:txBody>
+      </p:sp>
+      <p:sp>
+        <p:nvSpPr>
+          <p:cNvPr id="12" name="TextBox 11"/>
           <p:cNvSpPr txBox="1"/>
           <p:nvPr/>
         </p:nvSpPr>
         <p:spPr>
           <a:xfrm>
-            <a:off x="11526203" y="6492240"/>
-            <a:ext cx="360997" cy="246221"/>
+            <a:off x="6818888" y="3874429"/>
+            <a:ext cx="651140" cy="323165"/>
           </a:xfrm>
           <a:prstGeom prst="rect">
             <a:avLst/>
@@ -10371,19 +10739,793 @@
           </a:bodyPr>
           <a:lstStyle/>
           <a:p>
+            <a:pPr algn="l">
+              <a:spcAft>
+                <a:spcPts val="0"/>
+              </a:spcAft>
+            </a:pPr>
+            <a:r>
+              <a:rPr lang="ru-RU" sz="1500" b="1" dirty="0">
+                <a:solidFill>
+                  <a:srgbClr val="1A1A1A"/>
+                </a:solidFill>
+                <a:latin typeface="Arial"/>
+              </a:rPr>
+              <a:t>Дана</a:t>
+            </a:r>
+            <a:endParaRPr sz="1500" b="1" dirty="0">
+              <a:solidFill>
+                <a:srgbClr val="1A1A1A"/>
+              </a:solidFill>
+              <a:latin typeface="Arial"/>
+            </a:endParaRPr>
+          </a:p>
+        </p:txBody>
+      </p:sp>
+      <p:sp>
+        <p:nvSpPr>
+          <p:cNvPr id="13" name="TextBox 12"/>
+          <p:cNvSpPr txBox="1"/>
+          <p:nvPr/>
+        </p:nvSpPr>
+        <p:spPr>
+          <a:xfrm>
+            <a:off x="6818888" y="4251011"/>
+            <a:ext cx="3246120" cy="1492716"/>
+          </a:xfrm>
+          <a:prstGeom prst="rect">
+            <a:avLst/>
+          </a:prstGeom>
+          <a:noFill/>
+        </p:spPr>
+        <p:txBody>
+          <a:bodyPr wrap="square">
+            <a:spAutoFit/>
+          </a:bodyPr>
+          <a:lstStyle/>
+          <a:p>
+            <a:pPr algn="l">
+              <a:spcAft>
+                <a:spcPts val="400"/>
+              </a:spcAft>
+            </a:pPr>
+            <a:r>
+              <a:rPr lang="en-US" sz="1300" b="0" dirty="0">
+                <a:solidFill>
+                  <a:srgbClr val="5C5C62"/>
+                </a:solidFill>
+                <a:latin typeface="Arial"/>
+              </a:rPr>
+              <a:t>Backend &amp; </a:t>
+            </a:r>
+            <a:r>
+              <a:rPr lang="en-US" sz="1300" b="0" dirty="0" err="1">
+                <a:solidFill>
+                  <a:srgbClr val="5C5C62"/>
+                </a:solidFill>
+                <a:latin typeface="Arial"/>
+              </a:rPr>
+              <a:t>Gamedev</a:t>
+            </a:r>
+            <a:r>
+              <a:rPr lang="en-US" sz="1300" b="0" dirty="0">
+                <a:solidFill>
+                  <a:srgbClr val="5C5C62"/>
+                </a:solidFill>
+                <a:latin typeface="Arial"/>
+              </a:rPr>
+              <a:t> </a:t>
+            </a:r>
+            <a:r>
+              <a:rPr lang="ru-RU" sz="1300" b="0" dirty="0">
+                <a:solidFill>
+                  <a:srgbClr val="5C5C62"/>
+                </a:solidFill>
+                <a:latin typeface="Arial"/>
+              </a:rPr>
+              <a:t>разработчик</a:t>
+            </a:r>
+            <a:br>
+              <a:rPr lang="en-US" sz="1300" b="0" dirty="0">
+                <a:solidFill>
+                  <a:srgbClr val="5C5C62"/>
+                </a:solidFill>
+                <a:latin typeface="Arial"/>
+              </a:rPr>
+            </a:br>
+            <a:br>
+              <a:rPr lang="en-US" sz="1300" b="0" dirty="0">
+                <a:solidFill>
+                  <a:srgbClr val="5C5C62"/>
+                </a:solidFill>
+                <a:latin typeface="Arial"/>
+              </a:rPr>
+            </a:br>
+            <a:r>
+              <a:rPr lang="ru-RU" sz="1300" b="0" dirty="0">
+                <a:solidFill>
+                  <a:srgbClr val="5C5C62"/>
+                </a:solidFill>
+                <a:latin typeface="Arial"/>
+              </a:rPr>
+              <a:t>- Голос модели</a:t>
+            </a:r>
+            <a:br>
+              <a:rPr lang="ru-RU" sz="1300" b="0" dirty="0">
+                <a:solidFill>
+                  <a:srgbClr val="5C5C62"/>
+                </a:solidFill>
+                <a:latin typeface="Arial"/>
+              </a:rPr>
+            </a:br>
+            <a:r>
+              <a:rPr lang="ru-RU" sz="1300" b="0" dirty="0">
+                <a:solidFill>
+                  <a:srgbClr val="5C5C62"/>
+                </a:solidFill>
+                <a:latin typeface="Arial"/>
+              </a:rPr>
+              <a:t>- Обработка сервера</a:t>
+            </a:r>
+            <a:br>
+              <a:rPr lang="ru-RU" sz="1300" b="0" dirty="0">
+                <a:solidFill>
+                  <a:srgbClr val="5C5C62"/>
+                </a:solidFill>
+                <a:latin typeface="Arial"/>
+              </a:rPr>
+            </a:br>
+            <a:r>
+              <a:rPr lang="ru-RU" sz="1300" b="0" dirty="0">
+                <a:solidFill>
+                  <a:srgbClr val="5C5C62"/>
+                </a:solidFill>
+                <a:latin typeface="Arial"/>
+              </a:rPr>
+              <a:t>- Настройка шаблонов </a:t>
+            </a:r>
+            <a:br>
+              <a:rPr lang="en-US" sz="1300" b="0" dirty="0">
+                <a:solidFill>
+                  <a:srgbClr val="5C5C62"/>
+                </a:solidFill>
+                <a:latin typeface="Arial"/>
+              </a:rPr>
+            </a:br>
+            <a:br>
+              <a:rPr lang="en-US" sz="1300" b="0" dirty="0">
+                <a:solidFill>
+                  <a:srgbClr val="5C5C62"/>
+                </a:solidFill>
+                <a:latin typeface="Arial"/>
+              </a:rPr>
+            </a:br>
+            <a:r>
+              <a:rPr lang="ru-RU" sz="1300" b="0" dirty="0">
+                <a:solidFill>
+                  <a:srgbClr val="5C5C62"/>
+                </a:solidFill>
+                <a:latin typeface="Arial"/>
+              </a:rPr>
+              <a:t>Связаться: </a:t>
+            </a:r>
+            <a:r>
+              <a:rPr lang="en-US" sz="1300" b="0" dirty="0">
+                <a:solidFill>
+                  <a:srgbClr val="5C5C62"/>
+                </a:solidFill>
+                <a:latin typeface="Arial"/>
+              </a:rPr>
+              <a:t>@IKnowAllYourSecretss</a:t>
+            </a:r>
+            <a:endParaRPr lang="ru-RU" sz="1300" b="0" dirty="0">
+              <a:solidFill>
+                <a:srgbClr val="5C5C62"/>
+              </a:solidFill>
+              <a:latin typeface="Arial"/>
+            </a:endParaRPr>
+          </a:p>
+        </p:txBody>
+      </p:sp>
+      <p:sp>
+        <p:nvSpPr>
+          <p:cNvPr id="18" name="TextBox 17"/>
+          <p:cNvSpPr txBox="1"/>
+          <p:nvPr/>
+        </p:nvSpPr>
+        <p:spPr>
+          <a:xfrm>
+            <a:off x="502920" y="6492240"/>
+            <a:ext cx="9144000" cy="256032"/>
+          </a:xfrm>
+          <a:prstGeom prst="rect">
+            <a:avLst/>
+          </a:prstGeom>
+          <a:noFill/>
+        </p:spPr>
+        <p:txBody>
+          <a:bodyPr wrap="none">
+            <a:spAutoFit/>
+          </a:bodyPr>
+          <a:lstStyle/>
+          <a:p>
+            <a:pPr algn="l">
+              <a:spcAft>
+                <a:spcPts val="0"/>
+              </a:spcAft>
+            </a:pPr>
+            <a:r>
+              <a:rPr sz="1000" b="0" dirty="0">
+                <a:solidFill>
+                  <a:srgbClr val="8A8A90"/>
+                </a:solidFill>
+                <a:latin typeface="Arial"/>
+              </a:rPr>
+              <a:t>ИИ-</a:t>
+            </a:r>
+            <a:r>
+              <a:rPr sz="1000" b="0" dirty="0" err="1">
+                <a:solidFill>
+                  <a:srgbClr val="8A8A90"/>
+                </a:solidFill>
+                <a:latin typeface="Arial"/>
+              </a:rPr>
+              <a:t>секретарь</a:t>
+            </a:r>
+            <a:r>
+              <a:rPr sz="1000" b="0" dirty="0">
+                <a:solidFill>
+                  <a:srgbClr val="8A8A90"/>
+                </a:solidFill>
+                <a:latin typeface="Arial"/>
+              </a:rPr>
+              <a:t> </a:t>
+            </a:r>
+            <a:r>
+              <a:rPr sz="1000" b="0" dirty="0" err="1">
+                <a:solidFill>
+                  <a:srgbClr val="8A8A90"/>
+                </a:solidFill>
+                <a:latin typeface="Arial"/>
+              </a:rPr>
+              <a:t>входящих</a:t>
+            </a:r>
+            <a:r>
+              <a:rPr sz="1000" b="0" dirty="0">
+                <a:solidFill>
+                  <a:srgbClr val="8A8A90"/>
+                </a:solidFill>
+                <a:latin typeface="Arial"/>
+              </a:rPr>
+              <a:t> · </a:t>
+            </a:r>
+            <a:r>
+              <a:rPr sz="1000" b="0" dirty="0" err="1">
+                <a:solidFill>
+                  <a:srgbClr val="8A8A90"/>
+                </a:solidFill>
+                <a:latin typeface="Arial"/>
+              </a:rPr>
+              <a:t>прототип</a:t>
+            </a:r>
+            <a:r>
+              <a:rPr sz="1000" b="0" dirty="0">
+                <a:solidFill>
+                  <a:srgbClr val="8A8A90"/>
+                </a:solidFill>
+                <a:latin typeface="Arial"/>
+              </a:rPr>
+              <a:t> </a:t>
+            </a:r>
+            <a:r>
+              <a:rPr sz="1000" b="0" dirty="0" err="1">
+                <a:solidFill>
+                  <a:srgbClr val="8A8A90"/>
+                </a:solidFill>
+                <a:latin typeface="Arial"/>
+              </a:rPr>
+              <a:t>для</a:t>
+            </a:r>
+            <a:r>
+              <a:rPr sz="1000" b="0" dirty="0">
+                <a:solidFill>
+                  <a:srgbClr val="8A8A90"/>
+                </a:solidFill>
+                <a:latin typeface="Arial"/>
+              </a:rPr>
+              <a:t> МТС</a:t>
+            </a:r>
+          </a:p>
+        </p:txBody>
+      </p:sp>
+      <p:sp>
+        <p:nvSpPr>
+          <p:cNvPr id="19" name="TextBox 18"/>
+          <p:cNvSpPr txBox="1"/>
+          <p:nvPr/>
+        </p:nvSpPr>
+        <p:spPr>
+          <a:xfrm>
+            <a:off x="11526203" y="6492240"/>
+            <a:ext cx="360997" cy="246221"/>
+          </a:xfrm>
+          <a:prstGeom prst="rect">
+            <a:avLst/>
+          </a:prstGeom>
+          <a:noFill/>
+        </p:spPr>
+        <p:txBody>
+          <a:bodyPr wrap="none">
+            <a:spAutoFit/>
+          </a:bodyPr>
+          <a:lstStyle/>
+          <a:p>
             <a:pPr algn="r">
               <a:spcAft>
                 <a:spcPts val="0"/>
               </a:spcAft>
             </a:pPr>
             <a:r>
-              <a:rPr lang="en-US" sz="1000" b="0" dirty="0">
+              <a:rPr sz="1000">
                 <a:solidFill>
                   <a:srgbClr val="8A8A90"/>
                 </a:solidFill>
                 <a:latin typeface="Arial"/>
               </a:rPr>
-              <a:t>8/8</a:t>
+              <a:t>8/9</a:t>
+            </a:r>
+            <a:endParaRPr sz="1000" b="0" dirty="0">
+              <a:solidFill>
+                <a:srgbClr val="8A8A90"/>
+              </a:solidFill>
+              <a:latin typeface="Arial"/>
+            </a:endParaRPr>
+          </a:p>
+        </p:txBody>
+      </p:sp>
+      <p:pic>
+        <p:nvPicPr>
+          <p:cNvPr id="20" name="Рисунок 19">
+            <a:extLst>
+              <a:ext uri="{FF2B5EF4-FFF2-40B4-BE49-F238E27FC236}">
+                <a16:creationId xmlns:a16="http://schemas.microsoft.com/office/drawing/2014/main" id="{121F706B-0E09-42B7-ABB3-344146453099}"/>
+              </a:ext>
+            </a:extLst>
+          </p:cNvPr>
+          <p:cNvPicPr>
+            <a:picLocks noChangeAspect="1"/>
+          </p:cNvPicPr>
+          <p:nvPr/>
+        </p:nvPicPr>
+        <p:blipFill>
+          <a:blip r:embed="rId2"/>
+          <a:stretch>
+            <a:fillRect/>
+          </a:stretch>
+        </p:blipFill>
+        <p:spPr>
+          <a:xfrm>
+            <a:off x="7484346" y="1874520"/>
+            <a:ext cx="2161492" cy="2161492"/>
+          </a:xfrm>
+          <a:prstGeom prst="ellipse">
+            <a:avLst/>
+          </a:prstGeom>
+        </p:spPr>
+      </p:pic>
+      <p:pic>
+        <p:nvPicPr>
+          <p:cNvPr id="1026" name="Picture 2" descr="profile-avatar">
+            <a:extLst>
+              <a:ext uri="{FF2B5EF4-FFF2-40B4-BE49-F238E27FC236}">
+                <a16:creationId xmlns:a16="http://schemas.microsoft.com/office/drawing/2014/main" id="{C581D9DE-73EC-4579-A095-6CEEABFB8138}"/>
+              </a:ext>
+            </a:extLst>
+          </p:cNvPr>
+          <p:cNvPicPr>
+            <a:picLocks noChangeAspect="1" noChangeArrowheads="1"/>
+          </p:cNvPicPr>
+          <p:nvPr/>
+        </p:nvPicPr>
+        <p:blipFill>
+          <a:blip r:embed="rId3">
+            <a:extLst>
+              <a:ext uri="{28A0092B-C50C-407E-A947-70E740481C1C}">
+                <a14:useLocalDpi xmlns:a14="http://schemas.microsoft.com/office/drawing/2010/main" val="0"/>
+              </a:ext>
+            </a:extLst>
+          </a:blip>
+          <a:srcRect/>
+          <a:stretch>
+            <a:fillRect/>
+          </a:stretch>
+        </p:blipFill>
+        <p:spPr bwMode="auto">
+          <a:xfrm>
+            <a:off x="2570923" y="1898614"/>
+            <a:ext cx="2210972" cy="2210972"/>
+          </a:xfrm>
+          <a:prstGeom prst="ellipse">
+            <a:avLst/>
+          </a:prstGeom>
+          <a:noFill/>
+          <a:extLst>
+            <a:ext uri="{909E8E84-426E-40DD-AFC4-6F175D3DCCD1}">
+              <a14:hiddenFill xmlns:a14="http://schemas.microsoft.com/office/drawing/2010/main">
+                <a:solidFill>
+                  <a:srgbClr val="FFFFFF"/>
+                </a:solidFill>
+              </a14:hiddenFill>
+            </a:ext>
+          </a:extLst>
+        </p:spPr>
+      </p:pic>
+    </p:spTree>
+    <p:extLst>
+      <p:ext uri="{BB962C8B-B14F-4D97-AF65-F5344CB8AC3E}">
+        <p14:creationId xmlns:p14="http://schemas.microsoft.com/office/powerpoint/2010/main" val="4257334031"/>
+      </p:ext>
+    </p:extLst>
+  </p:cSld>
+  <p:clrMapOvr>
+    <a:masterClrMapping/>
+  </p:clrMapOvr>
+</p:sld>
+</file>
+
+<file path=ppt/slides/slide9.xml><?xml version="1.0" encoding="utf-8"?>
+<p:sld xmlns:a="http://schemas.openxmlformats.org/drawingml/2006/main" xmlns:r="http://schemas.openxmlformats.org/officeDocument/2006/relationships" xmlns:p="http://schemas.openxmlformats.org/presentationml/2006/main">
+  <p:cSld>
+    <p:bg>
+      <p:bgPr>
+        <a:solidFill>
+          <a:srgbClr val="F2F2F4"/>
+        </a:solidFill>
+        <a:effectLst/>
+      </p:bgPr>
+    </p:bg>
+    <p:spTree>
+      <p:nvGrpSpPr>
+        <p:cNvPr id="1" name=""/>
+        <p:cNvGrpSpPr/>
+        <p:nvPr/>
+      </p:nvGrpSpPr>
+      <p:grpSpPr>
+        <a:xfrm>
+          <a:off x="0" y="0"/>
+          <a:ext cx="0" cy="0"/>
+          <a:chOff x="0" y="0"/>
+          <a:chExt cx="0" cy="0"/>
+        </a:xfrm>
+      </p:grpSpPr>
+      <p:sp>
+        <p:nvSpPr>
+          <p:cNvPr id="2" name="Rectangle 1"/>
+          <p:cNvSpPr/>
+          <p:nvPr/>
+        </p:nvSpPr>
+        <p:spPr>
+          <a:xfrm>
+            <a:off x="0" y="0"/>
+            <a:ext cx="12191695" cy="384048"/>
+          </a:xfrm>
+          <a:prstGeom prst="rect">
+            <a:avLst/>
+          </a:prstGeom>
+          <a:solidFill>
+            <a:srgbClr val="E30611"/>
+          </a:solidFill>
+          <a:ln>
+            <a:noFill/>
+          </a:ln>
+        </p:spPr>
+        <p:style>
+          <a:lnRef idx="1">
+            <a:schemeClr val="accent1"/>
+          </a:lnRef>
+          <a:fillRef idx="3">
+            <a:schemeClr val="accent1"/>
+          </a:fillRef>
+          <a:effectRef idx="2">
+            <a:schemeClr val="accent1"/>
+          </a:effectRef>
+          <a:fontRef idx="minor">
+            <a:schemeClr val="lt1"/>
+          </a:fontRef>
+        </p:style>
+        <p:txBody>
+          <a:bodyPr rtlCol="0" anchor="ctr"/>
+          <a:lstStyle/>
+          <a:p>
+            <a:pPr algn="ctr"/>
+            <a:endParaRPr/>
+          </a:p>
+        </p:txBody>
+      </p:sp>
+      <p:sp>
+        <p:nvSpPr>
+          <p:cNvPr id="3" name="TextBox 2"/>
+          <p:cNvSpPr txBox="1"/>
+          <p:nvPr/>
+        </p:nvSpPr>
+        <p:spPr>
+          <a:xfrm>
+            <a:off x="502920" y="54864"/>
+            <a:ext cx="1566454" cy="261610"/>
+          </a:xfrm>
+          <a:prstGeom prst="rect">
+            <a:avLst/>
+          </a:prstGeom>
+          <a:noFill/>
+        </p:spPr>
+        <p:txBody>
+          <a:bodyPr wrap="none">
+            <a:spAutoFit/>
+          </a:bodyPr>
+          <a:lstStyle/>
+          <a:p>
+            <a:pPr algn="l">
+              <a:spcAft>
+                <a:spcPts val="0"/>
+              </a:spcAft>
+            </a:pPr>
+            <a:r>
+              <a:rPr lang="en-US" sz="1100" b="1" dirty="0" err="1">
+                <a:solidFill>
+                  <a:srgbClr val="FFFFFF"/>
+                </a:solidFill>
+                <a:latin typeface="Arial"/>
+              </a:rPr>
+              <a:t>StartUp</a:t>
+            </a:r>
+            <a:r>
+              <a:rPr lang="en-US" sz="1100" b="1" dirty="0">
+                <a:solidFill>
+                  <a:srgbClr val="FFFFFF"/>
+                </a:solidFill>
+                <a:latin typeface="Arial"/>
+              </a:rPr>
+              <a:t> Space VSTU</a:t>
+            </a:r>
+          </a:p>
+        </p:txBody>
+      </p:sp>
+      <p:sp>
+        <p:nvSpPr>
+          <p:cNvPr id="4" name="TextBox 3"/>
+          <p:cNvSpPr txBox="1"/>
+          <p:nvPr/>
+        </p:nvSpPr>
+        <p:spPr>
+          <a:xfrm>
+            <a:off x="502920" y="594360"/>
+            <a:ext cx="11155680" cy="553998"/>
+          </a:xfrm>
+          <a:prstGeom prst="rect">
+            <a:avLst/>
+          </a:prstGeom>
+          <a:noFill/>
+        </p:spPr>
+        <p:txBody>
+          <a:bodyPr wrap="square">
+            <a:spAutoFit/>
+          </a:bodyPr>
+          <a:lstStyle/>
+          <a:p>
+            <a:pPr algn="l">
+              <a:spcAft>
+                <a:spcPts val="400"/>
+              </a:spcAft>
+            </a:pPr>
+            <a:r>
+              <a:rPr lang="ru-RU" sz="3000" b="1" dirty="0">
+                <a:solidFill>
+                  <a:srgbClr val="1A1A1A"/>
+                </a:solidFill>
+                <a:latin typeface="Arial"/>
+              </a:rPr>
+              <a:t>Вопросы и ответы</a:t>
+            </a:r>
+            <a:endParaRPr sz="3000" b="1" dirty="0">
+              <a:solidFill>
+                <a:srgbClr val="1A1A1A"/>
+              </a:solidFill>
+              <a:latin typeface="Arial"/>
+            </a:endParaRPr>
+          </a:p>
+        </p:txBody>
+      </p:sp>
+      <p:sp>
+        <p:nvSpPr>
+          <p:cNvPr id="5" name="TextBox 4"/>
+          <p:cNvSpPr txBox="1"/>
+          <p:nvPr/>
+        </p:nvSpPr>
+        <p:spPr>
+          <a:xfrm>
+            <a:off x="502920" y="1097280"/>
+            <a:ext cx="3908891" cy="323165"/>
+          </a:xfrm>
+          <a:prstGeom prst="rect">
+            <a:avLst/>
+          </a:prstGeom>
+          <a:noFill/>
+        </p:spPr>
+        <p:txBody>
+          <a:bodyPr wrap="none">
+            <a:spAutoFit/>
+          </a:bodyPr>
+          <a:lstStyle/>
+          <a:p>
+            <a:pPr algn="l">
+              <a:spcAft>
+                <a:spcPts val="0"/>
+              </a:spcAft>
+            </a:pPr>
+            <a:r>
+              <a:rPr lang="ru-RU" sz="1500" b="0" dirty="0">
+                <a:solidFill>
+                  <a:srgbClr val="5C5C62"/>
+                </a:solidFill>
+                <a:latin typeface="Arial"/>
+              </a:rPr>
+              <a:t>Буду рад ответить на возникшие вопросы</a:t>
+            </a:r>
+            <a:endParaRPr sz="1500" b="0" dirty="0">
+              <a:solidFill>
+                <a:srgbClr val="5C5C62"/>
+              </a:solidFill>
+              <a:latin typeface="Arial"/>
+            </a:endParaRPr>
+          </a:p>
+        </p:txBody>
+      </p:sp>
+      <p:sp>
+        <p:nvSpPr>
+          <p:cNvPr id="18" name="TextBox 17"/>
+          <p:cNvSpPr txBox="1"/>
+          <p:nvPr/>
+        </p:nvSpPr>
+        <p:spPr>
+          <a:xfrm>
+            <a:off x="502920" y="6492240"/>
+            <a:ext cx="9144000" cy="256032"/>
+          </a:xfrm>
+          <a:prstGeom prst="rect">
+            <a:avLst/>
+          </a:prstGeom>
+          <a:noFill/>
+        </p:spPr>
+        <p:txBody>
+          <a:bodyPr wrap="none">
+            <a:spAutoFit/>
+          </a:bodyPr>
+          <a:lstStyle/>
+          <a:p>
+            <a:pPr algn="l">
+              <a:spcAft>
+                <a:spcPts val="0"/>
+              </a:spcAft>
+            </a:pPr>
+            <a:r>
+              <a:rPr sz="1000" b="0" dirty="0">
+                <a:solidFill>
+                  <a:srgbClr val="8A8A90"/>
+                </a:solidFill>
+                <a:latin typeface="Arial"/>
+              </a:rPr>
+              <a:t>ИИ-</a:t>
+            </a:r>
+            <a:r>
+              <a:rPr sz="1000" b="0" dirty="0" err="1">
+                <a:solidFill>
+                  <a:srgbClr val="8A8A90"/>
+                </a:solidFill>
+                <a:latin typeface="Arial"/>
+              </a:rPr>
+              <a:t>секретарь</a:t>
+            </a:r>
+            <a:r>
+              <a:rPr sz="1000" b="0" dirty="0">
+                <a:solidFill>
+                  <a:srgbClr val="8A8A90"/>
+                </a:solidFill>
+                <a:latin typeface="Arial"/>
+              </a:rPr>
+              <a:t> </a:t>
+            </a:r>
+            <a:r>
+              <a:rPr sz="1000" b="0" dirty="0" err="1">
+                <a:solidFill>
+                  <a:srgbClr val="8A8A90"/>
+                </a:solidFill>
+                <a:latin typeface="Arial"/>
+              </a:rPr>
+              <a:t>входящих</a:t>
+            </a:r>
+            <a:r>
+              <a:rPr sz="1000" b="0" dirty="0">
+                <a:solidFill>
+                  <a:srgbClr val="8A8A90"/>
+                </a:solidFill>
+                <a:latin typeface="Arial"/>
+              </a:rPr>
+              <a:t> · </a:t>
+            </a:r>
+            <a:r>
+              <a:rPr sz="1000" b="0" dirty="0" err="1">
+                <a:solidFill>
+                  <a:srgbClr val="8A8A90"/>
+                </a:solidFill>
+                <a:latin typeface="Arial"/>
+              </a:rPr>
+              <a:t>прототип</a:t>
+            </a:r>
+            <a:r>
+              <a:rPr sz="1000" b="0" dirty="0">
+                <a:solidFill>
+                  <a:srgbClr val="8A8A90"/>
+                </a:solidFill>
+                <a:latin typeface="Arial"/>
+              </a:rPr>
+              <a:t> </a:t>
+            </a:r>
+            <a:r>
+              <a:rPr sz="1000" b="0" dirty="0" err="1">
+                <a:solidFill>
+                  <a:srgbClr val="8A8A90"/>
+                </a:solidFill>
+                <a:latin typeface="Arial"/>
+              </a:rPr>
+              <a:t>для</a:t>
+            </a:r>
+            <a:r>
+              <a:rPr sz="1000" b="0" dirty="0">
+                <a:solidFill>
+                  <a:srgbClr val="8A8A90"/>
+                </a:solidFill>
+                <a:latin typeface="Arial"/>
+              </a:rPr>
+              <a:t> МТС</a:t>
+            </a:r>
+          </a:p>
+        </p:txBody>
+      </p:sp>
+      <p:sp>
+        <p:nvSpPr>
+          <p:cNvPr id="19" name="TextBox 18"/>
+          <p:cNvSpPr txBox="1"/>
+          <p:nvPr/>
+        </p:nvSpPr>
+        <p:spPr>
+          <a:xfrm>
+            <a:off x="11526203" y="6492240"/>
+            <a:ext cx="360997" cy="246221"/>
+          </a:xfrm>
+          <a:prstGeom prst="rect">
+            <a:avLst/>
+          </a:prstGeom>
+          <a:noFill/>
+        </p:spPr>
+        <p:txBody>
+          <a:bodyPr wrap="none">
+            <a:spAutoFit/>
+          </a:bodyPr>
+          <a:lstStyle/>
+          <a:p>
+            <a:pPr algn="r">
+              <a:spcAft>
+                <a:spcPts val="0"/>
+              </a:spcAft>
+            </a:pPr>
+            <a:r>
+              <a:rPr sz="1000">
+                <a:solidFill>
+                  <a:srgbClr val="8A8A90"/>
+                </a:solidFill>
+                <a:latin typeface="Arial"/>
+              </a:rPr>
+              <a:t>9/9</a:t>
             </a:r>
             <a:endParaRPr sz="1000" b="0" dirty="0">
               <a:solidFill>

</xml_diff>

<commit_message>
fix(ui): declutter dashboard/settings; harden TG bind checks for overnight demo
Remove duplicate bot summary and try-call CTAs, keep one-time MTS bind-token flow, add TG bind security tests, and sync pitch slide 7 into the main deck.
</commit_message>
<xml_diff>
--- a/docs/presentation_track1.pptx
+++ b/docs/presentation_track1.pptx
@@ -11,9 +11,9 @@
     <p:sldId id="259" r:id="rId5"/>
     <p:sldId id="261" r:id="rId6"/>
     <p:sldId id="265" r:id="rId7"/>
-    <p:sldId id="268" r:id="rId14"/>
-    <p:sldId id="267" r:id="rId8"/>
-    <p:sldId id="266" r:id="rId9"/>
+    <p:sldId id="268" r:id="rId8"/>
+    <p:sldId id="267" r:id="rId9"/>
+    <p:sldId id="266" r:id="rId10"/>
   </p:sldIdLst>
   <p:sldSz cx="12192000" cy="6858000"/>
   <p:notesSz cx="6858000" cy="9144000"/>
@@ -7219,7 +7219,7 @@
         <p:spPr>
           <a:xfrm>
             <a:off x="502920" y="1097280"/>
-            <a:ext cx="11155680" cy="411480"/>
+            <a:ext cx="5596276" cy="323165"/>
           </a:xfrm>
           <a:prstGeom prst="rect">
             <a:avLst/>
@@ -7238,14 +7238,65 @@
               </a:spcAft>
             </a:pPr>
             <a:r>
-              <a:rPr sz="1500" b="0">
-                <a:solidFill>
-                  <a:srgbClr val="5C5C62"/>
-                </a:solidFill>
-                <a:latin typeface="Arial"/>
-              </a:rPr>
-              <a:t>Стек под демо жюри: быстро поднять, честно показать fallback.</a:t>
-            </a:r>
+              <a:rPr lang="en-US" sz="1500" b="0" dirty="0" err="1">
+                <a:solidFill>
+                  <a:srgbClr val="5C5C62"/>
+                </a:solidFill>
+                <a:latin typeface="Arial"/>
+              </a:rPr>
+              <a:t>FallBack</a:t>
+            </a:r>
+            <a:r>
+              <a:rPr lang="en-US" sz="1500" b="0" dirty="0">
+                <a:solidFill>
+                  <a:srgbClr val="5C5C62"/>
+                </a:solidFill>
+                <a:latin typeface="Arial"/>
+              </a:rPr>
+              <a:t> </a:t>
+            </a:r>
+            <a:r>
+              <a:rPr lang="ru-RU" sz="1500" b="0" dirty="0">
+                <a:solidFill>
+                  <a:srgbClr val="5C5C62"/>
+                </a:solidFill>
+                <a:latin typeface="Arial"/>
+              </a:rPr>
+              <a:t>проекта: </a:t>
+            </a:r>
+            <a:r>
+              <a:rPr lang="ru-RU" sz="1500" b="0" dirty="0" err="1">
+                <a:solidFill>
+                  <a:srgbClr val="5C5C62"/>
+                </a:solidFill>
+                <a:latin typeface="Arial"/>
+              </a:rPr>
+              <a:t>Клинето</a:t>
+            </a:r>
+            <a:r>
+              <a:rPr lang="ru-RU" sz="1500" b="0" dirty="0">
+                <a:solidFill>
+                  <a:srgbClr val="5C5C62"/>
+                </a:solidFill>
+                <a:latin typeface="Arial"/>
+              </a:rPr>
+              <a:t>-серверная архитектура на </a:t>
+            </a:r>
+            <a:r>
+              <a:rPr lang="en-US" sz="1500" dirty="0">
+                <a:solidFill>
+                  <a:srgbClr val="5C5C62"/>
+                </a:solidFill>
+                <a:latin typeface="Arial"/>
+              </a:rPr>
+              <a:t>Python</a:t>
+            </a:r>
+            <a:endParaRPr sz="1500" b="0" dirty="0">
+              <a:solidFill>
+                <a:srgbClr val="5C5C62"/>
+              </a:solidFill>
+              <a:latin typeface="Arial"/>
+            </a:endParaRPr>
           </a:p>
         </p:txBody>
       </p:sp>
@@ -8891,7 +8942,7 @@
 </file>
 
 <file path=ppt/slides/slide7.xml><?xml version="1.0" encoding="utf-8"?>
-<p:sld xmlns:a="http://schemas.openxmlformats.org/drawingml/2006/main" xmlns:p="http://schemas.openxmlformats.org/presentationml/2006/main" xmlns:r="http://schemas.openxmlformats.org/officeDocument/2006/relationships">
+<p:sld xmlns:a="http://schemas.openxmlformats.org/drawingml/2006/main" xmlns:r="http://schemas.openxmlformats.org/officeDocument/2006/relationships" xmlns:p="http://schemas.openxmlformats.org/presentationml/2006/main">
   <p:cSld>
     <p:bg>
       <p:bgPr>
@@ -8907,7 +8958,14 @@
         <p:cNvGrpSpPr/>
         <p:nvPr/>
       </p:nvGrpSpPr>
-      <p:grpSpPr/>
+      <p:grpSpPr>
+        <a:xfrm>
+          <a:off x="0" y="0"/>
+          <a:ext cx="0" cy="0"/>
+          <a:chOff x="0" y="0"/>
+          <a:chExt cx="0" cy="0"/>
+        </a:xfrm>
+      </p:grpSpPr>
       <p:sp>
         <p:nvSpPr>
           <p:cNvPr id="2" name="Rectangle 1"/>
@@ -8948,6 +9006,7 @@
           <a:lstStyle/>
           <a:p>
             <a:pPr algn="ctr"/>
+            <a:endParaRPr/>
           </a:p>
         </p:txBody>
       </p:sp>
@@ -9110,6 +9169,7 @@
           <a:lstStyle/>
           <a:p>
             <a:pPr algn="ctr"/>
+            <a:endParaRPr/>
           </a:p>
         </p:txBody>
       </p:sp>
@@ -9153,6 +9213,7 @@
           <a:lstStyle/>
           <a:p>
             <a:pPr algn="ctr"/>
+            <a:endParaRPr/>
           </a:p>
         </p:txBody>
       </p:sp>
@@ -9223,13 +9284,58 @@
               </a:spcAft>
             </a:pPr>
             <a:r>
-              <a:rPr sz="1200" b="0">
-                <a:solidFill>
-                  <a:srgbClr val="5C5C62"/>
-                </a:solidFill>
-                <a:latin typeface="Arial"/>
-              </a:rPr>
-              <a:t>модулей автотестов — API, UI, TG, речь, live-call</a:t>
+              <a:rPr sz="1200" b="0" dirty="0" err="1">
+                <a:solidFill>
+                  <a:srgbClr val="5C5C62"/>
+                </a:solidFill>
+                <a:latin typeface="Arial"/>
+              </a:rPr>
+              <a:t>модулей</a:t>
+            </a:r>
+            <a:r>
+              <a:rPr sz="1200" b="0" dirty="0">
+                <a:solidFill>
+                  <a:srgbClr val="5C5C62"/>
+                </a:solidFill>
+                <a:latin typeface="Arial"/>
+              </a:rPr>
+              <a:t> </a:t>
+            </a:r>
+            <a:r>
+              <a:rPr sz="1200" b="0" dirty="0" err="1">
+                <a:solidFill>
+                  <a:srgbClr val="5C5C62"/>
+                </a:solidFill>
+                <a:latin typeface="Arial"/>
+              </a:rPr>
+              <a:t>автотестов</a:t>
+            </a:r>
+            <a:r>
+              <a:rPr sz="1200" b="0" dirty="0">
+                <a:solidFill>
+                  <a:srgbClr val="5C5C62"/>
+                </a:solidFill>
+                <a:latin typeface="Arial"/>
+              </a:rPr>
+              <a:t> — API, UI, TG, </a:t>
+            </a:r>
+            <a:r>
+              <a:rPr sz="1200" b="0" dirty="0" err="1">
+                <a:solidFill>
+                  <a:srgbClr val="5C5C62"/>
+                </a:solidFill>
+                <a:latin typeface="Arial"/>
+              </a:rPr>
+              <a:t>речь</a:t>
+            </a:r>
+            <a:r>
+              <a:rPr sz="1200" b="0" dirty="0">
+                <a:solidFill>
+                  <a:srgbClr val="5C5C62"/>
+                </a:solidFill>
+                <a:latin typeface="Arial"/>
+              </a:rPr>
+              <a:t>, live-call</a:t>
             </a:r>
           </a:p>
         </p:txBody>
@@ -9276,6 +9382,7 @@
           <a:lstStyle/>
           <a:p>
             <a:pPr algn="ctr"/>
+            <a:endParaRPr/>
           </a:p>
         </p:txBody>
       </p:sp>
@@ -9319,6 +9426,7 @@
           <a:lstStyle/>
           <a:p>
             <a:pPr algn="ctr"/>
+            <a:endParaRPr/>
           </a:p>
         </p:txBody>
       </p:sp>
@@ -9442,6 +9550,7 @@
           <a:lstStyle/>
           <a:p>
             <a:pPr algn="ctr"/>
+            <a:endParaRPr/>
           </a:p>
         </p:txBody>
       </p:sp>
@@ -9485,6 +9594,7 @@
           <a:lstStyle/>
           <a:p>
             <a:pPr algn="ctr"/>
+            <a:endParaRPr/>
           </a:p>
         </p:txBody>
       </p:sp>
@@ -9608,6 +9718,7 @@
           <a:lstStyle/>
           <a:p>
             <a:pPr algn="ctr"/>
+            <a:endParaRPr/>
           </a:p>
         </p:txBody>
       </p:sp>
@@ -9651,6 +9762,7 @@
           <a:lstStyle/>
           <a:p>
             <a:pPr algn="ctr"/>
+            <a:endParaRPr/>
           </a:p>
         </p:txBody>
       </p:sp>
@@ -9838,6 +9950,7 @@
           <a:lstStyle/>
           <a:p>
             <a:pPr algn="ctr"/>
+            <a:endParaRPr/>
           </a:p>
         </p:txBody>
       </p:sp>
@@ -9881,6 +9994,7 @@
           <a:lstStyle/>
           <a:p>
             <a:pPr algn="ctr"/>
+            <a:endParaRPr/>
           </a:p>
         </p:txBody>
       </p:sp>

</xml_diff>

<commit_message>
docs(pitch): sync presentation_track1.pptx for demo deck
Upload the current 9-slide customer pitch including the tests and analytics slide.
</commit_message>
<xml_diff>
--- a/docs/presentation_track1.pptx
+++ b/docs/presentation_track1.pptx
@@ -310,7 +310,7 @@
           <a:p>
             <a:fld id="{5BCAD085-E8A6-8845-BD4E-CB4CCA059FC4}" type="datetimeFigureOut">
               <a:rPr lang="en-US" smtClean="0"/>
-              <a:t>10/7/2026</a:t>
+              <a:t>10/8/2026</a:t>
             </a:fld>
             <a:endParaRPr lang="en-US"/>
           </a:p>
@@ -478,7 +478,7 @@
           <a:p>
             <a:fld id="{5BCAD085-E8A6-8845-BD4E-CB4CCA059FC4}" type="datetimeFigureOut">
               <a:rPr lang="en-US" smtClean="0"/>
-              <a:t>10/7/2026</a:t>
+              <a:t>10/8/2026</a:t>
             </a:fld>
             <a:endParaRPr lang="en-US"/>
           </a:p>
@@ -656,7 +656,7 @@
           <a:p>
             <a:fld id="{5BCAD085-E8A6-8845-BD4E-CB4CCA059FC4}" type="datetimeFigureOut">
               <a:rPr lang="en-US" smtClean="0"/>
-              <a:t>10/7/2026</a:t>
+              <a:t>10/8/2026</a:t>
             </a:fld>
             <a:endParaRPr lang="en-US"/>
           </a:p>
@@ -824,7 +824,7 @@
           <a:p>
             <a:fld id="{5BCAD085-E8A6-8845-BD4E-CB4CCA059FC4}" type="datetimeFigureOut">
               <a:rPr lang="en-US" smtClean="0"/>
-              <a:t>10/7/2026</a:t>
+              <a:t>10/8/2026</a:t>
             </a:fld>
             <a:endParaRPr lang="en-US"/>
           </a:p>
@@ -1069,7 +1069,7 @@
           <a:p>
             <a:fld id="{5BCAD085-E8A6-8845-BD4E-CB4CCA059FC4}" type="datetimeFigureOut">
               <a:rPr lang="en-US" smtClean="0"/>
-              <a:t>10/7/2026</a:t>
+              <a:t>10/8/2026</a:t>
             </a:fld>
             <a:endParaRPr lang="en-US"/>
           </a:p>
@@ -1354,7 +1354,7 @@
           <a:p>
             <a:fld id="{5BCAD085-E8A6-8845-BD4E-CB4CCA059FC4}" type="datetimeFigureOut">
               <a:rPr lang="en-US" smtClean="0"/>
-              <a:t>10/7/2026</a:t>
+              <a:t>10/8/2026</a:t>
             </a:fld>
             <a:endParaRPr lang="en-US"/>
           </a:p>
@@ -1773,7 +1773,7 @@
           <a:p>
             <a:fld id="{5BCAD085-E8A6-8845-BD4E-CB4CCA059FC4}" type="datetimeFigureOut">
               <a:rPr lang="en-US" smtClean="0"/>
-              <a:t>10/7/2026</a:t>
+              <a:t>10/8/2026</a:t>
             </a:fld>
             <a:endParaRPr lang="en-US"/>
           </a:p>
@@ -1890,7 +1890,7 @@
           <a:p>
             <a:fld id="{5BCAD085-E8A6-8845-BD4E-CB4CCA059FC4}" type="datetimeFigureOut">
               <a:rPr lang="en-US" smtClean="0"/>
-              <a:t>10/7/2026</a:t>
+              <a:t>10/8/2026</a:t>
             </a:fld>
             <a:endParaRPr lang="en-US"/>
           </a:p>
@@ -1985,7 +1985,7 @@
           <a:p>
             <a:fld id="{5BCAD085-E8A6-8845-BD4E-CB4CCA059FC4}" type="datetimeFigureOut">
               <a:rPr lang="en-US" smtClean="0"/>
-              <a:t>10/7/2026</a:t>
+              <a:t>10/8/2026</a:t>
             </a:fld>
             <a:endParaRPr lang="en-US"/>
           </a:p>
@@ -2260,7 +2260,7 @@
           <a:p>
             <a:fld id="{5BCAD085-E8A6-8845-BD4E-CB4CCA059FC4}" type="datetimeFigureOut">
               <a:rPr lang="en-US" smtClean="0"/>
-              <a:t>10/7/2026</a:t>
+              <a:t>10/8/2026</a:t>
             </a:fld>
             <a:endParaRPr lang="en-US"/>
           </a:p>
@@ -2512,7 +2512,7 @@
           <a:p>
             <a:fld id="{5BCAD085-E8A6-8845-BD4E-CB4CCA059FC4}" type="datetimeFigureOut">
               <a:rPr lang="en-US" smtClean="0"/>
-              <a:t>10/7/2026</a:t>
+              <a:t>10/8/2026</a:t>
             </a:fld>
             <a:endParaRPr lang="en-US"/>
           </a:p>
@@ -2723,7 +2723,7 @@
           <a:p>
             <a:fld id="{5BCAD085-E8A6-8845-BD4E-CB4CCA059FC4}" type="datetimeFigureOut">
               <a:rPr lang="en-US" smtClean="0"/>
-              <a:t>10/7/2026</a:t>
+              <a:t>10/8/2026</a:t>
             </a:fld>
             <a:endParaRPr lang="en-US"/>
           </a:p>
@@ -9265,7 +9265,7 @@
         <p:spPr>
           <a:xfrm>
             <a:off x="685800" y="2212848"/>
-            <a:ext cx="3246120" cy="411480"/>
+            <a:ext cx="3383280" cy="461665"/>
           </a:xfrm>
           <a:prstGeom prst="rect">
             <a:avLst/>
@@ -9273,7 +9273,7 @@
           <a:noFill/>
         </p:spPr>
         <p:txBody>
-          <a:bodyPr wrap="none">
+          <a:bodyPr wrap="square">
             <a:spAutoFit/>
           </a:bodyPr>
           <a:lstStyle/>
@@ -9833,13 +9833,40 @@
               </a:spcAft>
             </a:pPr>
             <a:r>
-              <a:rPr sz="1300" b="0">
-                <a:solidFill>
-                  <a:srgbClr val="5C5C62"/>
-                </a:solidFill>
-                <a:latin typeface="Arial"/>
-              </a:rPr>
-              <a:t>Контракты API, LLM, routing, шаблоны, hotline</a:t>
+              <a:rPr sz="1300" b="0" dirty="0" err="1">
+                <a:solidFill>
+                  <a:srgbClr val="5C5C62"/>
+                </a:solidFill>
+                <a:latin typeface="Arial"/>
+              </a:rPr>
+              <a:t>Контракты</a:t>
+            </a:r>
+            <a:r>
+              <a:rPr sz="1300" b="0" dirty="0">
+                <a:solidFill>
+                  <a:srgbClr val="5C5C62"/>
+                </a:solidFill>
+                <a:latin typeface="Arial"/>
+              </a:rPr>
+              <a:t> API, LLM, routing, </a:t>
+            </a:r>
+            <a:r>
+              <a:rPr sz="1300" b="0" dirty="0" err="1">
+                <a:solidFill>
+                  <a:srgbClr val="5C5C62"/>
+                </a:solidFill>
+                <a:latin typeface="Arial"/>
+              </a:rPr>
+              <a:t>шаблоны</a:t>
+            </a:r>
+            <a:r>
+              <a:rPr sz="1300" b="0" dirty="0">
+                <a:solidFill>
+                  <a:srgbClr val="5C5C62"/>
+                </a:solidFill>
+                <a:latin typeface="Arial"/>
+              </a:rPr>
+              <a:t>, hotline</a:t>
             </a:r>
           </a:p>
           <a:p>
@@ -9849,14 +9876,47 @@
               </a:spcAft>
             </a:pPr>
             <a:r>
-              <a:rPr sz="1300" b="0">
-                <a:solidFill>
-                  <a:srgbClr val="5C5C62"/>
-                </a:solidFill>
-                <a:latin typeface="Arial"/>
-              </a:rPr>
-              <a:t>Live-call: VAD, barge-in, многоходовый диалог</a:t>
-            </a:r>
+              <a:rPr sz="1300" b="0" dirty="0">
+                <a:solidFill>
+                  <a:srgbClr val="5C5C62"/>
+                </a:solidFill>
+                <a:latin typeface="Arial"/>
+              </a:rPr>
+              <a:t>Live-call: VAD, barge-in, </a:t>
+            </a:r>
+            <a:r>
+              <a:rPr sz="1300" b="0" dirty="0" err="1">
+                <a:solidFill>
+                  <a:srgbClr val="5C5C62"/>
+                </a:solidFill>
+                <a:latin typeface="Arial"/>
+              </a:rPr>
+              <a:t>многоходовый</a:t>
+            </a:r>
+            <a:r>
+              <a:rPr sz="1300" b="0" dirty="0">
+                <a:solidFill>
+                  <a:srgbClr val="5C5C62"/>
+                </a:solidFill>
+                <a:latin typeface="Arial"/>
+              </a:rPr>
+              <a:t> </a:t>
+            </a:r>
+            <a:r>
+              <a:rPr sz="1300" b="0" dirty="0" err="1">
+                <a:solidFill>
+                  <a:srgbClr val="5C5C62"/>
+                </a:solidFill>
+                <a:latin typeface="Arial"/>
+              </a:rPr>
+              <a:t>диалог</a:t>
+            </a:r>
+            <a:endParaRPr sz="1300" b="0" dirty="0">
+              <a:solidFill>
+                <a:srgbClr val="5C5C62"/>
+              </a:solidFill>
+              <a:latin typeface="Arial"/>
+            </a:endParaRPr>
           </a:p>
           <a:p>
             <a:pPr algn="l">
@@ -9865,14 +9925,74 @@
               </a:spcAft>
             </a:pPr>
             <a:r>
-              <a:rPr sz="1300" b="0">
-                <a:solidFill>
-                  <a:srgbClr val="5C5C62"/>
-                </a:solidFill>
-                <a:latin typeface="Arial"/>
-              </a:rPr>
-              <a:t>Flet UI + Telegram-дашборд + изоляция линий</a:t>
-            </a:r>
+              <a:rPr sz="1300" b="0" dirty="0" err="1">
+                <a:solidFill>
+                  <a:srgbClr val="5C5C62"/>
+                </a:solidFill>
+                <a:latin typeface="Arial"/>
+              </a:rPr>
+              <a:t>Flet</a:t>
+            </a:r>
+            <a:r>
+              <a:rPr sz="1300" b="0" dirty="0">
+                <a:solidFill>
+                  <a:srgbClr val="5C5C62"/>
+                </a:solidFill>
+                <a:latin typeface="Arial"/>
+              </a:rPr>
+              <a:t> UI + Telegram-</a:t>
+            </a:r>
+            <a:r>
+              <a:rPr sz="1300" b="0" dirty="0" err="1">
+                <a:solidFill>
+                  <a:srgbClr val="5C5C62"/>
+                </a:solidFill>
+                <a:latin typeface="Arial"/>
+              </a:rPr>
+              <a:t>дашборд</a:t>
+            </a:r>
+            <a:r>
+              <a:rPr sz="1300" b="0" dirty="0">
+                <a:solidFill>
+                  <a:srgbClr val="5C5C62"/>
+                </a:solidFill>
+                <a:latin typeface="Arial"/>
+              </a:rPr>
+              <a:t> + </a:t>
+            </a:r>
+            <a:r>
+              <a:rPr sz="1300" b="0" dirty="0" err="1">
+                <a:solidFill>
+                  <a:srgbClr val="5C5C62"/>
+                </a:solidFill>
+                <a:latin typeface="Arial"/>
+              </a:rPr>
+              <a:t>изоляция</a:t>
+            </a:r>
+            <a:r>
+              <a:rPr sz="1300" b="0" dirty="0">
+                <a:solidFill>
+                  <a:srgbClr val="5C5C62"/>
+                </a:solidFill>
+                <a:latin typeface="Arial"/>
+              </a:rPr>
+              <a:t> </a:t>
+            </a:r>
+            <a:r>
+              <a:rPr sz="1300" b="0" dirty="0" err="1">
+                <a:solidFill>
+                  <a:srgbClr val="5C5C62"/>
+                </a:solidFill>
+                <a:latin typeface="Arial"/>
+              </a:rPr>
+              <a:t>линий</a:t>
+            </a:r>
+            <a:endParaRPr sz="1300" b="0" dirty="0">
+              <a:solidFill>
+                <a:srgbClr val="5C5C62"/>
+              </a:solidFill>
+              <a:latin typeface="Arial"/>
+            </a:endParaRPr>
           </a:p>
           <a:p>
             <a:pPr algn="l">
@@ -9881,14 +10001,47 @@
               </a:spcAft>
             </a:pPr>
             <a:r>
-              <a:rPr sz="1300" b="0">
-                <a:solidFill>
-                  <a:srgbClr val="5C5C62"/>
-                </a:solidFill>
-                <a:latin typeface="Arial"/>
-              </a:rPr>
-              <a:t>Fallback: Yandex недоступен → Whisper / edge-tts</a:t>
-            </a:r>
+              <a:rPr sz="1300" b="0" dirty="0">
+                <a:solidFill>
+                  <a:srgbClr val="5C5C62"/>
+                </a:solidFill>
+                <a:latin typeface="Arial"/>
+              </a:rPr>
+              <a:t>Fallback: Yandex </a:t>
+            </a:r>
+            <a:r>
+              <a:rPr sz="1300" b="0" dirty="0" err="1">
+                <a:solidFill>
+                  <a:srgbClr val="5C5C62"/>
+                </a:solidFill>
+                <a:latin typeface="Arial"/>
+              </a:rPr>
+              <a:t>недоступен</a:t>
+            </a:r>
+            <a:r>
+              <a:rPr sz="1300" b="0" dirty="0">
+                <a:solidFill>
+                  <a:srgbClr val="5C5C62"/>
+                </a:solidFill>
+                <a:latin typeface="Arial"/>
+              </a:rPr>
+              <a:t> → Whisper / edge-</a:t>
+            </a:r>
+            <a:r>
+              <a:rPr sz="1300" b="0" dirty="0" err="1">
+                <a:solidFill>
+                  <a:srgbClr val="5C5C62"/>
+                </a:solidFill>
+                <a:latin typeface="Arial"/>
+              </a:rPr>
+              <a:t>tts</a:t>
+            </a:r>
+            <a:endParaRPr sz="1300" b="0" dirty="0">
+              <a:solidFill>
+                <a:srgbClr val="5C5C62"/>
+              </a:solidFill>
+              <a:latin typeface="Arial"/>
+            </a:endParaRPr>
           </a:p>
           <a:p>
             <a:pPr algn="l">
@@ -9897,13 +10050,22 @@
               </a:spcAft>
             </a:pPr>
             <a:r>
-              <a:rPr sz="1300" b="0">
-                <a:solidFill>
-                  <a:srgbClr val="5C5C62"/>
-                </a:solidFill>
-                <a:latin typeface="Arial"/>
-              </a:rPr>
-              <a:t>Аналитика: /calls/stats, critical / intent / action</a:t>
+              <a:rPr sz="1300" b="0" dirty="0" err="1">
+                <a:solidFill>
+                  <a:srgbClr val="5C5C62"/>
+                </a:solidFill>
+                <a:latin typeface="Arial"/>
+              </a:rPr>
+              <a:t>Аналитика</a:t>
+            </a:r>
+            <a:r>
+              <a:rPr sz="1300" b="0" dirty="0">
+                <a:solidFill>
+                  <a:srgbClr val="5C5C62"/>
+                </a:solidFill>
+                <a:latin typeface="Arial"/>
+              </a:rPr>
+              <a:t>: /calls/stats, critical / intent / action</a:t>
             </a:r>
           </a:p>
         </p:txBody>

</xml_diff>